<commit_message>
docs: regenerate PPTX with updated speaker assignments
</commit_message>
<xml_diff>
--- a/X-AURUM_Presentation.pptx
+++ b/X-AURUM_Presentation.pptx
@@ -4144,7 +4144,7 @@
                   <a:srgbClr val="F5C518"/>
                 </a:solidFill>
               </a:rPr>
-              <a:t>🎙  Quốc Đạt</a:t>
+              <a:t>🎙  Thành Trung</a:t>
             </a:r>
           </a:p>
         </p:txBody>
@@ -4824,7 +4824,7 @@
                   <a:srgbClr val="F5C518"/>
                 </a:solidFill>
               </a:rPr>
-              <a:t>🎙  Quốc Đạt</a:t>
+              <a:t>🎙  Thành Trung</a:t>
             </a:r>
           </a:p>
         </p:txBody>
@@ -5815,7 +5815,7 @@
                   <a:srgbClr val="F5C518"/>
                 </a:solidFill>
               </a:rPr>
-              <a:t>🎙  Quốc Đạt</a:t>
+              <a:t>🎙  Thành Trung</a:t>
             </a:r>
           </a:p>
         </p:txBody>
@@ -6764,7 +6764,7 @@
                   <a:srgbClr val="FFFFFF"/>
                 </a:solidFill>
               </a:rPr>
-              <a:t>Thành Trung</a:t>
+              <a:t>Xuân Hương</a:t>
             </a:r>
           </a:p>
         </p:txBody>
@@ -6918,7 +6918,7 @@
                   <a:srgbClr val="FFFFFF"/>
                 </a:solidFill>
               </a:rPr>
-              <a:t>Xuân Hương</a:t>
+              <a:t>Quốc Đạt</a:t>
             </a:r>
           </a:p>
         </p:txBody>
@@ -7226,7 +7226,7 @@
                   <a:srgbClr val="FFFFFF"/>
                 </a:solidFill>
               </a:rPr>
-              <a:t>Quốc Đạt</a:t>
+              <a:t>Thành Trung</a:t>
             </a:r>
           </a:p>
         </p:txBody>
@@ -7440,7 +7440,7 @@
                   <a:srgbClr val="F5C518"/>
                 </a:solidFill>
               </a:rPr>
-              <a:t>🎙  Thành Trung</a:t>
+              <a:t>🎙  Xuân Hương</a:t>
             </a:r>
           </a:p>
         </p:txBody>
@@ -7981,7 +7981,7 @@
                   <a:srgbClr val="F5C518"/>
                 </a:solidFill>
               </a:rPr>
-              <a:t>🎙  Thành Trung</a:t>
+              <a:t>🎙  Xuân Hương</a:t>
             </a:r>
           </a:p>
         </p:txBody>
@@ -9051,7 +9051,7 @@
                   <a:srgbClr val="F5C518"/>
                 </a:solidFill>
               </a:rPr>
-              <a:t>🎙  Thành Trung</a:t>
+              <a:t>🎙  Xuân Hương</a:t>
             </a:r>
           </a:p>
         </p:txBody>
@@ -9623,7 +9623,7 @@
                   <a:srgbClr val="F5C518"/>
                 </a:solidFill>
               </a:rPr>
-              <a:t>🎙  Xuân Hương</a:t>
+              <a:t>🎙  Quốc Đạt</a:t>
             </a:r>
           </a:p>
         </p:txBody>
@@ -10360,7 +10360,7 @@
                   <a:srgbClr val="F5C518"/>
                 </a:solidFill>
               </a:rPr>
-              <a:t>🎙  Xuân Hương</a:t>
+              <a:t>🎙  Quốc Đạt</a:t>
             </a:r>
           </a:p>
         </p:txBody>
@@ -11007,7 +11007,7 @@
                   <a:srgbClr val="F5C518"/>
                 </a:solidFill>
               </a:rPr>
-              <a:t>🎙  Xuân Hương</a:t>
+              <a:t>🎙  Quốc Đạt</a:t>
             </a:r>
           </a:p>
         </p:txBody>

</xml_diff>

<commit_message>
docs: move Trung to 3rd speaker (slides 7-9 DevOps), Nguyen to 4th (slides 10-12 Security)
</commit_message>
<xml_diff>
--- a/X-AURUM_Presentation.pptx
+++ b/X-AURUM_Presentation.pptx
@@ -19,6 +19,9 @@
     <p:sldId id="267" r:id="rId18"/>
     <p:sldId id="268" r:id="rId19"/>
     <p:sldId id="269" r:id="rId20"/>
+    <p:sldId id="270" r:id="rId21"/>
+    <p:sldId id="271" r:id="rId22"/>
+    <p:sldId id="272" r:id="rId23"/>
   </p:sldIdLst>
   <p:sldSz cx="12188952" cy="6858000" type="screen4x3"/>
   <p:notesSz cx="6858000" cy="9144000"/>
@@ -4178,7 +4181,7 @@
                   <a:srgbClr val="FFFFFF"/>
                 </a:solidFill>
               </a:rPr>
-              <a:t>Slide 10 · Docker - Đóng Gói &amp; Chuẩn Hóa Môi Trường</a:t>
+              <a:t>Slide 7 · Docker - Đóng Gói &amp; Chuẩn Hóa Môi Trường</a:t>
             </a:r>
           </a:p>
         </p:txBody>
@@ -4858,7 +4861,7 @@
                   <a:srgbClr val="FFFFFF"/>
                 </a:solidFill>
               </a:rPr>
-              <a:t>Slide 11 · CI/CD &amp; Triển Khai Trên nttspace.online</a:t>
+              <a:t>Slide 8 · CI/CD &amp; Triển Khai Trên nttspace.online</a:t>
             </a:r>
           </a:p>
         </p:txBody>
@@ -5849,7 +5852,7 @@
                   <a:srgbClr val="FFFFFF"/>
                 </a:solidFill>
               </a:rPr>
-              <a:t>Slide 12 · Live Demo Trên Swagger</a:t>
+              <a:t>Slide 9 · Live Demo Trên Swagger</a:t>
             </a:r>
           </a:p>
         </p:txBody>
@@ -6461,7 +6464,7 @@
         <p:spPr>
           <a:xfrm>
             <a:off x="0" y="0"/>
-            <a:ext cx="12188952" cy="109728"/>
+            <a:ext cx="12188952" cy="73152"/>
           </a:xfrm>
           <a:prstGeom prst="rect">
             <a:avLst/>
@@ -6503,8 +6506,119 @@
         </p:nvSpPr>
         <p:spPr>
           <a:xfrm>
-            <a:off x="0" y="6748272"/>
-            <a:ext cx="12188952" cy="109728"/>
+            <a:off x="0" y="73152"/>
+            <a:ext cx="2560320" cy="411480"/>
+          </a:xfrm>
+          <a:prstGeom prst="rect">
+            <a:avLst/>
+          </a:prstGeom>
+          <a:solidFill>
+            <a:srgbClr val="1E1E1E"/>
+          </a:solidFill>
+          <a:ln>
+            <a:noFill/>
+          </a:ln>
+        </p:spPr>
+        <p:style>
+          <a:lnRef idx="1">
+            <a:schemeClr val="accent1"/>
+          </a:lnRef>
+          <a:fillRef idx="3">
+            <a:schemeClr val="accent1"/>
+          </a:fillRef>
+          <a:effectRef idx="2">
+            <a:schemeClr val="accent1"/>
+          </a:effectRef>
+          <a:fontRef idx="minor">
+            <a:schemeClr val="lt1"/>
+          </a:fontRef>
+        </p:style>
+        <p:txBody>
+          <a:bodyPr rtlCol="0" anchor="ctr"/>
+          <a:lstStyle/>
+          <a:p>
+            <a:pPr algn="ctr"/>
+          </a:p>
+        </p:txBody>
+      </p:sp>
+      <p:sp>
+        <p:nvSpPr>
+          <p:cNvPr id="4" name="TextBox 3"/>
+          <p:cNvSpPr txBox="1"/>
+          <p:nvPr/>
+        </p:nvSpPr>
+        <p:spPr>
+          <a:xfrm>
+            <a:off x="91440" y="73152"/>
+            <a:ext cx="2377440" cy="411480"/>
+          </a:xfrm>
+          <a:prstGeom prst="rect">
+            <a:avLst/>
+          </a:prstGeom>
+          <a:noFill/>
+        </p:spPr>
+        <p:txBody>
+          <a:bodyPr wrap="square">
+            <a:spAutoFit/>
+          </a:bodyPr>
+          <a:lstStyle/>
+          <a:p>
+            <a:pPr algn="l"/>
+            <a:r>
+              <a:rPr sz="1100" b="0" i="0">
+                <a:solidFill>
+                  <a:srgbClr val="F5C518"/>
+                </a:solidFill>
+              </a:rPr>
+              <a:t>🎙  Văn Nguyễn</a:t>
+            </a:r>
+          </a:p>
+        </p:txBody>
+      </p:sp>
+      <p:sp>
+        <p:nvSpPr>
+          <p:cNvPr id="5" name="TextBox 4"/>
+          <p:cNvSpPr txBox="1"/>
+          <p:nvPr/>
+        </p:nvSpPr>
+        <p:spPr>
+          <a:xfrm>
+            <a:off x="457200" y="594360"/>
+            <a:ext cx="11247120" cy="685800"/>
+          </a:xfrm>
+          <a:prstGeom prst="rect">
+            <a:avLst/>
+          </a:prstGeom>
+          <a:noFill/>
+        </p:spPr>
+        <p:txBody>
+          <a:bodyPr wrap="square">
+            <a:spAutoFit/>
+          </a:bodyPr>
+          <a:lstStyle/>
+          <a:p>
+            <a:pPr algn="l"/>
+            <a:r>
+              <a:rPr sz="2800" b="1" i="0">
+                <a:solidFill>
+                  <a:srgbClr val="FFFFFF"/>
+                </a:solidFill>
+              </a:rPr>
+              <a:t>Slide 10 · Bài Toán Hiệu Năng - Hosting ML Model</a:t>
+            </a:r>
+          </a:p>
+        </p:txBody>
+      </p:sp>
+      <p:sp>
+        <p:nvSpPr>
+          <p:cNvPr id="6" name="Rectangle 5"/>
+          <p:cNvSpPr/>
+          <p:nvPr/>
+        </p:nvSpPr>
+        <p:spPr>
+          <a:xfrm>
+            <a:off x="0" y="1325880"/>
+            <a:ext cx="12188952" cy="36576"/>
           </a:xfrm>
           <a:prstGeom prst="rect">
             <a:avLst/>
@@ -6540,82 +6654,292 @@
       </p:sp>
       <p:sp>
         <p:nvSpPr>
-          <p:cNvPr id="4" name="TextBox 3"/>
-          <p:cNvSpPr txBox="1"/>
-          <p:nvPr/>
-        </p:nvSpPr>
-        <p:spPr>
-          <a:xfrm>
-            <a:off x="914400" y="914400"/>
-            <a:ext cx="10058400" cy="1097280"/>
-          </a:xfrm>
-          <a:prstGeom prst="rect">
-            <a:avLst/>
-          </a:prstGeom>
-          <a:noFill/>
-        </p:spPr>
-        <p:txBody>
-          <a:bodyPr wrap="square">
-            <a:spAutoFit/>
-          </a:bodyPr>
+          <p:cNvPr id="7" name="TextBox 6"/>
+          <p:cNvSpPr txBox="1"/>
+          <p:nvPr/>
+        </p:nvSpPr>
+        <p:spPr>
+          <a:xfrm>
+            <a:off x="457200" y="1463040"/>
+            <a:ext cx="10972800" cy="365760"/>
+          </a:xfrm>
+          <a:prstGeom prst="rect">
+            <a:avLst/>
+          </a:prstGeom>
+          <a:noFill/>
+        </p:spPr>
+        <p:txBody>
+          <a:bodyPr wrap="square">
+            <a:spAutoFit/>
+          </a:bodyPr>
+          <a:lstStyle/>
+          <a:p>
+            <a:pPr algn="l"/>
+            <a:r>
+              <a:rPr sz="1500" b="1" i="0">
+                <a:solidFill>
+                  <a:srgbClr val="F5C518"/>
+                </a:solidFill>
+              </a:rPr>
+              <a:t>Vấn đề đặc thù khi Host Machine Learning làm REST API:</a:t>
+            </a:r>
+          </a:p>
+        </p:txBody>
+      </p:sp>
+      <p:sp>
+        <p:nvSpPr>
+          <p:cNvPr id="8" name="TextBox 7"/>
+          <p:cNvSpPr txBox="1"/>
+          <p:nvPr/>
+        </p:nvSpPr>
+        <p:spPr>
+          <a:xfrm>
+            <a:off x="457200" y="1920240"/>
+            <a:ext cx="10972800" cy="365760"/>
+          </a:xfrm>
+          <a:prstGeom prst="rect">
+            <a:avLst/>
+          </a:prstGeom>
+          <a:noFill/>
+        </p:spPr>
+        <p:txBody>
+          <a:bodyPr wrap="square">
+            <a:spAutoFit/>
+          </a:bodyPr>
+          <a:lstStyle/>
+          <a:p>
+            <a:pPr algn="l"/>
+            <a:r>
+              <a:rPr sz="1500" b="0" i="0">
+                <a:solidFill>
+                  <a:srgbClr val="CCCCCC"/>
+                </a:solidFill>
+              </a:rPr>
+              <a:t>  •  File GoldModel.zip nặng ~43MB — chứa toàn bộ cấu trúc thần kinh nhân tạo.</a:t>
+            </a:r>
+          </a:p>
+        </p:txBody>
+      </p:sp>
+      <p:sp>
+        <p:nvSpPr>
+          <p:cNvPr id="9" name="TextBox 8"/>
+          <p:cNvSpPr txBox="1"/>
+          <p:nvPr/>
+        </p:nvSpPr>
+        <p:spPr>
+          <a:xfrm>
+            <a:off x="457200" y="2286000"/>
+            <a:ext cx="10972800" cy="365760"/>
+          </a:xfrm>
+          <a:prstGeom prst="rect">
+            <a:avLst/>
+          </a:prstGeom>
+          <a:noFill/>
+        </p:spPr>
+        <p:txBody>
+          <a:bodyPr wrap="square">
+            <a:spAutoFit/>
+          </a:bodyPr>
+          <a:lstStyle/>
+          <a:p>
+            <a:pPr algn="l"/>
+            <a:r>
+              <a:rPr sz="1500" b="0" i="0">
+                <a:solidFill>
+                  <a:srgbClr val="CCCCCC"/>
+                </a:solidFill>
+              </a:rPr>
+              <a:t>  •  Nếu nạp lại model mỗi lần có Request → Tốn hàng giây xử lý mỗi lượt gọi.</a:t>
+            </a:r>
+          </a:p>
+        </p:txBody>
+      </p:sp>
+      <p:sp>
+        <p:nvSpPr>
+          <p:cNvPr id="10" name="TextBox 9"/>
+          <p:cNvSpPr txBox="1"/>
+          <p:nvPr/>
+        </p:nvSpPr>
+        <p:spPr>
+          <a:xfrm>
+            <a:off x="457200" y="2651760"/>
+            <a:ext cx="10972800" cy="365760"/>
+          </a:xfrm>
+          <a:prstGeom prst="rect">
+            <a:avLst/>
+          </a:prstGeom>
+          <a:noFill/>
+        </p:spPr>
+        <p:txBody>
+          <a:bodyPr wrap="square">
+            <a:spAutoFit/>
+          </a:bodyPr>
+          <a:lstStyle/>
+          <a:p>
+            <a:pPr algn="l"/>
+            <a:r>
+              <a:rPr sz="1500" b="0" i="0">
+                <a:solidFill>
+                  <a:srgbClr val="CCCCCC"/>
+                </a:solidFill>
+              </a:rPr>
+              <a:t>  •  Hàng trăm người dùng đồng thời → Memory Leak → Server Crash.</a:t>
+            </a:r>
+          </a:p>
+        </p:txBody>
+      </p:sp>
+      <p:sp>
+        <p:nvSpPr>
+          <p:cNvPr id="11" name="TextBox 10"/>
+          <p:cNvSpPr txBox="1"/>
+          <p:nvPr/>
+        </p:nvSpPr>
+        <p:spPr>
+          <a:xfrm>
+            <a:off x="457200" y="2926080"/>
+            <a:ext cx="10972800" cy="365760"/>
+          </a:xfrm>
+          <a:prstGeom prst="rect">
+            <a:avLst/>
+          </a:prstGeom>
+          <a:noFill/>
+        </p:spPr>
+        <p:txBody>
+          <a:bodyPr wrap="square">
+            <a:spAutoFit/>
+          </a:bodyPr>
+          <a:lstStyle/>
+          <a:p>
+            <a:pPr algn="l"/>
+            <a:r>
+              <a:rPr sz="1500" b="1" i="0">
+                <a:solidFill>
+                  <a:srgbClr val="F87171"/>
+                </a:solidFill>
+              </a:rPr>
+              <a:t>Kịch bản nguy hiểm:</a:t>
+            </a:r>
+          </a:p>
+        </p:txBody>
+      </p:sp>
+      <p:sp>
+        <p:nvSpPr>
+          <p:cNvPr id="12" name="Rectangle 11"/>
+          <p:cNvSpPr/>
+          <p:nvPr/>
+        </p:nvSpPr>
+        <p:spPr>
+          <a:xfrm>
+            <a:off x="457200" y="3337560"/>
+            <a:ext cx="10972800" cy="1828800"/>
+          </a:xfrm>
+          <a:prstGeom prst="rect">
+            <a:avLst/>
+          </a:prstGeom>
+          <a:solidFill>
+            <a:srgbClr val="333333"/>
+          </a:solidFill>
+          <a:ln>
+            <a:noFill/>
+          </a:ln>
+        </p:spPr>
+        <p:style>
+          <a:lnRef idx="1">
+            <a:schemeClr val="accent1"/>
+          </a:lnRef>
+          <a:fillRef idx="3">
+            <a:schemeClr val="accent1"/>
+          </a:fillRef>
+          <a:effectRef idx="2">
+            <a:schemeClr val="accent1"/>
+          </a:effectRef>
+          <a:fontRef idx="minor">
+            <a:schemeClr val="lt1"/>
+          </a:fontRef>
+        </p:style>
+        <p:txBody>
+          <a:bodyPr rtlCol="0" anchor="ctr"/>
           <a:lstStyle/>
           <a:p>
             <a:pPr algn="ctr"/>
-            <a:r>
-              <a:rPr sz="4400" b="1" i="0">
+          </a:p>
+        </p:txBody>
+      </p:sp>
+      <p:sp>
+        <p:nvSpPr>
+          <p:cNvPr id="13" name="TextBox 12"/>
+          <p:cNvSpPr txBox="1"/>
+          <p:nvPr/>
+        </p:nvSpPr>
+        <p:spPr>
+          <a:xfrm>
+            <a:off x="548640" y="3410712"/>
+            <a:ext cx="10789920" cy="1828800"/>
+          </a:xfrm>
+          <a:prstGeom prst="rect">
+            <a:avLst/>
+          </a:prstGeom>
+          <a:noFill/>
+        </p:spPr>
+        <p:txBody>
+          <a:bodyPr wrap="square">
+            <a:spAutoFit/>
+          </a:bodyPr>
+          <a:lstStyle/>
+          <a:p>
+            <a:pPr algn="l"/>
+            <a:r>
+              <a:rPr sz="1100" b="0" i="0">
                 <a:solidFill>
                   <a:srgbClr val="F5C518"/>
                 </a:solidFill>
               </a:rPr>
-              <a:t>CẢM ƠN THẦY CÔ &amp; HỘI ĐỒNG!</a:t>
-            </a:r>
-          </a:p>
-        </p:txBody>
-      </p:sp>
-      <p:sp>
-        <p:nvSpPr>
-          <p:cNvPr id="5" name="TextBox 4"/>
-          <p:cNvSpPr txBox="1"/>
-          <p:nvPr/>
-        </p:nvSpPr>
-        <p:spPr>
-          <a:xfrm>
-            <a:off x="914400" y="2103120"/>
-            <a:ext cx="10058400" cy="548640"/>
-          </a:xfrm>
-          <a:prstGeom prst="rect">
-            <a:avLst/>
-          </a:prstGeom>
-          <a:noFill/>
-        </p:spPr>
-        <p:txBody>
-          <a:bodyPr wrap="square">
-            <a:spAutoFit/>
-          </a:bodyPr>
-          <a:lstStyle/>
-          <a:p>
-            <a:pPr algn="ctr"/>
-            <a:r>
-              <a:rPr sz="1800" b="0" i="1">
-                <a:solidFill>
-                  <a:srgbClr val="CCCCCC"/>
-                </a:solidFill>
-              </a:rPr>
-              <a:t>Nhóm 3 xin lắng nghe câu hỏi phản biện.</a:t>
-            </a:r>
-          </a:p>
-        </p:txBody>
-      </p:sp>
-      <p:sp>
-        <p:nvSpPr>
-          <p:cNvPr id="6" name="Rectangle 5"/>
+              <a:t>// ❌ Cách sai — nạp lại model mỗi request
+app.MapPost('/predict', (input) =&gt; {
+    var ctx = new MLContext();
+    var model = ctx.Model.Load('GoldModel.zip', ...);
+    // → RAM tăng vô hạn theo số lượng request
+});</a:t>
+            </a:r>
+          </a:p>
+        </p:txBody>
+      </p:sp>
+    </p:spTree>
+  </p:cSld>
+  <p:clrMapOvr>
+    <a:masterClrMapping/>
+  </p:clrMapOvr>
+</p:sld>
+</file>
+
+<file path=ppt/slides/slide15.xml><?xml version="1.0" encoding="utf-8"?>
+<p:sld xmlns:a="http://schemas.openxmlformats.org/drawingml/2006/main" xmlns:p="http://schemas.openxmlformats.org/presentationml/2006/main" xmlns:r="http://schemas.openxmlformats.org/officeDocument/2006/relationships">
+  <p:cSld>
+    <p:bg>
+      <p:bgPr>
+        <a:solidFill>
+          <a:srgbClr val="0D0D0D"/>
+        </a:solidFill>
+        <a:effectLst/>
+      </p:bgPr>
+    </p:bg>
+    <p:spTree>
+      <p:nvGrpSpPr>
+        <p:cNvPr id="1" name=""/>
+        <p:cNvGrpSpPr/>
+        <p:nvPr/>
+      </p:nvGrpSpPr>
+      <p:grpSpPr/>
+      <p:sp>
+        <p:nvSpPr>
+          <p:cNvPr id="2" name="Rectangle 1"/>
           <p:cNvSpPr/>
           <p:nvPr/>
         </p:nvSpPr>
         <p:spPr>
           <a:xfrm>
-            <a:off x="0" y="2834640"/>
-            <a:ext cx="12188952" cy="36576"/>
+            <a:off x="0" y="0"/>
+            <a:ext cx="12188952" cy="73152"/>
           </a:xfrm>
           <a:prstGeom prst="rect">
             <a:avLst/>
@@ -6651,6 +6975,1263 @@
       </p:sp>
       <p:sp>
         <p:nvSpPr>
+          <p:cNvPr id="3" name="Rectangle 2"/>
+          <p:cNvSpPr/>
+          <p:nvPr/>
+        </p:nvSpPr>
+        <p:spPr>
+          <a:xfrm>
+            <a:off x="0" y="73152"/>
+            <a:ext cx="2560320" cy="411480"/>
+          </a:xfrm>
+          <a:prstGeom prst="rect">
+            <a:avLst/>
+          </a:prstGeom>
+          <a:solidFill>
+            <a:srgbClr val="1E1E1E"/>
+          </a:solidFill>
+          <a:ln>
+            <a:noFill/>
+          </a:ln>
+        </p:spPr>
+        <p:style>
+          <a:lnRef idx="1">
+            <a:schemeClr val="accent1"/>
+          </a:lnRef>
+          <a:fillRef idx="3">
+            <a:schemeClr val="accent1"/>
+          </a:fillRef>
+          <a:effectRef idx="2">
+            <a:schemeClr val="accent1"/>
+          </a:effectRef>
+          <a:fontRef idx="minor">
+            <a:schemeClr val="lt1"/>
+          </a:fontRef>
+        </p:style>
+        <p:txBody>
+          <a:bodyPr rtlCol="0" anchor="ctr"/>
+          <a:lstStyle/>
+          <a:p>
+            <a:pPr algn="ctr"/>
+          </a:p>
+        </p:txBody>
+      </p:sp>
+      <p:sp>
+        <p:nvSpPr>
+          <p:cNvPr id="4" name="TextBox 3"/>
+          <p:cNvSpPr txBox="1"/>
+          <p:nvPr/>
+        </p:nvSpPr>
+        <p:spPr>
+          <a:xfrm>
+            <a:off x="91440" y="73152"/>
+            <a:ext cx="2377440" cy="411480"/>
+          </a:xfrm>
+          <a:prstGeom prst="rect">
+            <a:avLst/>
+          </a:prstGeom>
+          <a:noFill/>
+        </p:spPr>
+        <p:txBody>
+          <a:bodyPr wrap="square">
+            <a:spAutoFit/>
+          </a:bodyPr>
+          <a:lstStyle/>
+          <a:p>
+            <a:pPr algn="l"/>
+            <a:r>
+              <a:rPr sz="1100" b="0" i="0">
+                <a:solidFill>
+                  <a:srgbClr val="F5C518"/>
+                </a:solidFill>
+              </a:rPr>
+              <a:t>🎙  Văn Nguyễn</a:t>
+            </a:r>
+          </a:p>
+        </p:txBody>
+      </p:sp>
+      <p:sp>
+        <p:nvSpPr>
+          <p:cNvPr id="5" name="TextBox 4"/>
+          <p:cNvSpPr txBox="1"/>
+          <p:nvPr/>
+        </p:nvSpPr>
+        <p:spPr>
+          <a:xfrm>
+            <a:off x="457200" y="594360"/>
+            <a:ext cx="11247120" cy="685800"/>
+          </a:xfrm>
+          <a:prstGeom prst="rect">
+            <a:avLst/>
+          </a:prstGeom>
+          <a:noFill/>
+        </p:spPr>
+        <p:txBody>
+          <a:bodyPr wrap="square">
+            <a:spAutoFit/>
+          </a:bodyPr>
+          <a:lstStyle/>
+          <a:p>
+            <a:pPr algn="l"/>
+            <a:r>
+              <a:rPr sz="2800" b="1" i="0">
+                <a:solidFill>
+                  <a:srgbClr val="FFFFFF"/>
+                </a:solidFill>
+              </a:rPr>
+              <a:t>Slide 11 · PredictionEnginePool - Quản Trị RAM</a:t>
+            </a:r>
+          </a:p>
+        </p:txBody>
+      </p:sp>
+      <p:sp>
+        <p:nvSpPr>
+          <p:cNvPr id="6" name="Rectangle 5"/>
+          <p:cNvSpPr/>
+          <p:nvPr/>
+        </p:nvSpPr>
+        <p:spPr>
+          <a:xfrm>
+            <a:off x="0" y="1325880"/>
+            <a:ext cx="12188952" cy="36576"/>
+          </a:xfrm>
+          <a:prstGeom prst="rect">
+            <a:avLst/>
+          </a:prstGeom>
+          <a:solidFill>
+            <a:srgbClr val="F5C518"/>
+          </a:solidFill>
+          <a:ln>
+            <a:noFill/>
+          </a:ln>
+        </p:spPr>
+        <p:style>
+          <a:lnRef idx="1">
+            <a:schemeClr val="accent1"/>
+          </a:lnRef>
+          <a:fillRef idx="3">
+            <a:schemeClr val="accent1"/>
+          </a:fillRef>
+          <a:effectRef idx="2">
+            <a:schemeClr val="accent1"/>
+          </a:effectRef>
+          <a:fontRef idx="minor">
+            <a:schemeClr val="lt1"/>
+          </a:fontRef>
+        </p:style>
+        <p:txBody>
+          <a:bodyPr rtlCol="0" anchor="ctr"/>
+          <a:lstStyle/>
+          <a:p>
+            <a:pPr algn="ctr"/>
+          </a:p>
+        </p:txBody>
+      </p:sp>
+      <p:sp>
+        <p:nvSpPr>
+          <p:cNvPr id="7" name="TextBox 6"/>
+          <p:cNvSpPr txBox="1"/>
+          <p:nvPr/>
+        </p:nvSpPr>
+        <p:spPr>
+          <a:xfrm>
+            <a:off x="457200" y="1463040"/>
+            <a:ext cx="10972800" cy="365760"/>
+          </a:xfrm>
+          <a:prstGeom prst="rect">
+            <a:avLst/>
+          </a:prstGeom>
+          <a:noFill/>
+        </p:spPr>
+        <p:txBody>
+          <a:bodyPr wrap="square">
+            <a:spAutoFit/>
+          </a:bodyPr>
+          <a:lstStyle/>
+          <a:p>
+            <a:pPr algn="l"/>
+            <a:r>
+              <a:rPr sz="1500" b="1" i="0">
+                <a:solidFill>
+                  <a:srgbClr val="F5C518"/>
+                </a:solidFill>
+              </a:rPr>
+              <a:t>Giải pháp: PredictionEnginePool (Object Pooling)</a:t>
+            </a:r>
+          </a:p>
+        </p:txBody>
+      </p:sp>
+      <p:sp>
+        <p:nvSpPr>
+          <p:cNvPr id="8" name="Rectangle 7"/>
+          <p:cNvSpPr/>
+          <p:nvPr/>
+        </p:nvSpPr>
+        <p:spPr>
+          <a:xfrm>
+            <a:off x="457200" y="1920240"/>
+            <a:ext cx="10972800" cy="1554480"/>
+          </a:xfrm>
+          <a:prstGeom prst="rect">
+            <a:avLst/>
+          </a:prstGeom>
+          <a:solidFill>
+            <a:srgbClr val="333333"/>
+          </a:solidFill>
+          <a:ln>
+            <a:noFill/>
+          </a:ln>
+        </p:spPr>
+        <p:style>
+          <a:lnRef idx="1">
+            <a:schemeClr val="accent1"/>
+          </a:lnRef>
+          <a:fillRef idx="3">
+            <a:schemeClr val="accent1"/>
+          </a:fillRef>
+          <a:effectRef idx="2">
+            <a:schemeClr val="accent1"/>
+          </a:effectRef>
+          <a:fontRef idx="minor">
+            <a:schemeClr val="lt1"/>
+          </a:fontRef>
+        </p:style>
+        <p:txBody>
+          <a:bodyPr rtlCol="0" anchor="ctr"/>
+          <a:lstStyle/>
+          <a:p>
+            <a:pPr algn="ctr"/>
+          </a:p>
+        </p:txBody>
+      </p:sp>
+      <p:sp>
+        <p:nvSpPr>
+          <p:cNvPr id="9" name="TextBox 8"/>
+          <p:cNvSpPr txBox="1"/>
+          <p:nvPr/>
+        </p:nvSpPr>
+        <p:spPr>
+          <a:xfrm>
+            <a:off x="548640" y="1993392"/>
+            <a:ext cx="10789920" cy="1554480"/>
+          </a:xfrm>
+          <a:prstGeom prst="rect">
+            <a:avLst/>
+          </a:prstGeom>
+          <a:noFill/>
+        </p:spPr>
+        <p:txBody>
+          <a:bodyPr wrap="square">
+            <a:spAutoFit/>
+          </a:bodyPr>
+          <a:lstStyle/>
+          <a:p>
+            <a:pPr algn="l"/>
+            <a:r>
+              <a:rPr sz="1100" b="0" i="0">
+                <a:solidFill>
+                  <a:srgbClr val="F5C518"/>
+                </a:solidFill>
+              </a:rPr>
+              <a:t>// ✅ Đăng ký 1 lần duy nhất lúc Server khởi động
+builder.Services.AddPredictionEnginePool&lt;ModelInput, ModelOutput&gt;(
+    modelName: 'GoldModel',
+    modelBuilder: ctx =&gt; ctx.Model.Load('GoldModel.zip', ...)
+);</a:t>
+            </a:r>
+          </a:p>
+        </p:txBody>
+      </p:sp>
+      <p:sp>
+        <p:nvSpPr>
+          <p:cNvPr id="10" name="TextBox 9"/>
+          <p:cNvSpPr txBox="1"/>
+          <p:nvPr/>
+        </p:nvSpPr>
+        <p:spPr>
+          <a:xfrm>
+            <a:off x="457200" y="3017520"/>
+            <a:ext cx="10972800" cy="365760"/>
+          </a:xfrm>
+          <a:prstGeom prst="rect">
+            <a:avLst/>
+          </a:prstGeom>
+          <a:noFill/>
+        </p:spPr>
+        <p:txBody>
+          <a:bodyPr wrap="square">
+            <a:spAutoFit/>
+          </a:bodyPr>
+          <a:lstStyle/>
+          <a:p>
+            <a:pPr algn="l"/>
+            <a:r>
+              <a:rPr sz="1500" b="1" i="0">
+                <a:solidFill>
+                  <a:srgbClr val="F5C518"/>
+                </a:solidFill>
+              </a:rPr>
+              <a:t>Cơ chế hoạt động:</a:t>
+            </a:r>
+          </a:p>
+        </p:txBody>
+      </p:sp>
+      <p:sp>
+        <p:nvSpPr>
+          <p:cNvPr id="11" name="TextBox 10"/>
+          <p:cNvSpPr txBox="1"/>
+          <p:nvPr/>
+        </p:nvSpPr>
+        <p:spPr>
+          <a:xfrm>
+            <a:off x="457200" y="3429000"/>
+            <a:ext cx="5669280" cy="365760"/>
+          </a:xfrm>
+          <a:prstGeom prst="rect">
+            <a:avLst/>
+          </a:prstGeom>
+          <a:noFill/>
+        </p:spPr>
+        <p:txBody>
+          <a:bodyPr wrap="square">
+            <a:spAutoFit/>
+          </a:bodyPr>
+          <a:lstStyle/>
+          <a:p>
+            <a:pPr algn="l"/>
+            <a:r>
+              <a:rPr sz="1400" b="0" i="0">
+                <a:solidFill>
+                  <a:srgbClr val="CCCCCC"/>
+                </a:solidFill>
+              </a:rPr>
+              <a:t>  •  🟢  Server start → Nạp model vào RAM đúng 1 lần.</a:t>
+            </a:r>
+          </a:p>
+        </p:txBody>
+      </p:sp>
+      <p:sp>
+        <p:nvSpPr>
+          <p:cNvPr id="12" name="TextBox 11"/>
+          <p:cNvSpPr txBox="1"/>
+          <p:nvPr/>
+        </p:nvSpPr>
+        <p:spPr>
+          <a:xfrm>
+            <a:off x="457200" y="3794760"/>
+            <a:ext cx="5669280" cy="365760"/>
+          </a:xfrm>
+          <a:prstGeom prst="rect">
+            <a:avLst/>
+          </a:prstGeom>
+          <a:noFill/>
+        </p:spPr>
+        <p:txBody>
+          <a:bodyPr wrap="square">
+            <a:spAutoFit/>
+          </a:bodyPr>
+          <a:lstStyle/>
+          <a:p>
+            <a:pPr algn="l"/>
+            <a:r>
+              <a:rPr sz="1400" b="0" i="0">
+                <a:solidFill>
+                  <a:srgbClr val="CCCCCC"/>
+                </a:solidFill>
+              </a:rPr>
+              <a:t>  •  🔄  Request đến → Mượn Engine → Dự báo → Trả lại Pool.</a:t>
+            </a:r>
+          </a:p>
+        </p:txBody>
+      </p:sp>
+      <p:sp>
+        <p:nvSpPr>
+          <p:cNvPr id="13" name="TextBox 12"/>
+          <p:cNvSpPr txBox="1"/>
+          <p:nvPr/>
+        </p:nvSpPr>
+        <p:spPr>
+          <a:xfrm>
+            <a:off x="6217920" y="3429000"/>
+            <a:ext cx="5486400" cy="365760"/>
+          </a:xfrm>
+          <a:prstGeom prst="rect">
+            <a:avLst/>
+          </a:prstGeom>
+          <a:noFill/>
+        </p:spPr>
+        <p:txBody>
+          <a:bodyPr wrap="square">
+            <a:spAutoFit/>
+          </a:bodyPr>
+          <a:lstStyle/>
+          <a:p>
+            <a:pPr algn="l"/>
+            <a:r>
+              <a:rPr sz="1400" b="0" i="0">
+                <a:solidFill>
+                  <a:srgbClr val="CCCCCC"/>
+                </a:solidFill>
+              </a:rPr>
+              <a:t>  •  ✅  Thread-Safe: Ngàn requests song song, không xung đột.</a:t>
+            </a:r>
+          </a:p>
+        </p:txBody>
+      </p:sp>
+      <p:sp>
+        <p:nvSpPr>
+          <p:cNvPr id="14" name="TextBox 13"/>
+          <p:cNvSpPr txBox="1"/>
+          <p:nvPr/>
+        </p:nvSpPr>
+        <p:spPr>
+          <a:xfrm>
+            <a:off x="6217920" y="3794760"/>
+            <a:ext cx="5486400" cy="365760"/>
+          </a:xfrm>
+          <a:prstGeom prst="rect">
+            <a:avLst/>
+          </a:prstGeom>
+          <a:noFill/>
+        </p:spPr>
+        <p:txBody>
+          <a:bodyPr wrap="square">
+            <a:spAutoFit/>
+          </a:bodyPr>
+          <a:lstStyle/>
+          <a:p>
+            <a:pPr algn="l"/>
+            <a:r>
+              <a:rPr sz="1400" b="0" i="0">
+                <a:solidFill>
+                  <a:srgbClr val="CCCCCC"/>
+                </a:solidFill>
+              </a:rPr>
+              <a:t>  •  ✅  Zero Memory Leak: Pool tự quản lý vòng đời object.</a:t>
+            </a:r>
+          </a:p>
+        </p:txBody>
+      </p:sp>
+    </p:spTree>
+  </p:cSld>
+  <p:clrMapOvr>
+    <a:masterClrMapping/>
+  </p:clrMapOvr>
+</p:sld>
+</file>
+
+<file path=ppt/slides/slide16.xml><?xml version="1.0" encoding="utf-8"?>
+<p:sld xmlns:a="http://schemas.openxmlformats.org/drawingml/2006/main" xmlns:p="http://schemas.openxmlformats.org/presentationml/2006/main" xmlns:r="http://schemas.openxmlformats.org/officeDocument/2006/relationships">
+  <p:cSld>
+    <p:bg>
+      <p:bgPr>
+        <a:solidFill>
+          <a:srgbClr val="0D0D0D"/>
+        </a:solidFill>
+        <a:effectLst/>
+      </p:bgPr>
+    </p:bg>
+    <p:spTree>
+      <p:nvGrpSpPr>
+        <p:cNvPr id="1" name=""/>
+        <p:cNvGrpSpPr/>
+        <p:nvPr/>
+      </p:nvGrpSpPr>
+      <p:grpSpPr/>
+      <p:sp>
+        <p:nvSpPr>
+          <p:cNvPr id="2" name="Rectangle 1"/>
+          <p:cNvSpPr/>
+          <p:nvPr/>
+        </p:nvSpPr>
+        <p:spPr>
+          <a:xfrm>
+            <a:off x="0" y="0"/>
+            <a:ext cx="12188952" cy="73152"/>
+          </a:xfrm>
+          <a:prstGeom prst="rect">
+            <a:avLst/>
+          </a:prstGeom>
+          <a:solidFill>
+            <a:srgbClr val="F5C518"/>
+          </a:solidFill>
+          <a:ln>
+            <a:noFill/>
+          </a:ln>
+        </p:spPr>
+        <p:style>
+          <a:lnRef idx="1">
+            <a:schemeClr val="accent1"/>
+          </a:lnRef>
+          <a:fillRef idx="3">
+            <a:schemeClr val="accent1"/>
+          </a:fillRef>
+          <a:effectRef idx="2">
+            <a:schemeClr val="accent1"/>
+          </a:effectRef>
+          <a:fontRef idx="minor">
+            <a:schemeClr val="lt1"/>
+          </a:fontRef>
+        </p:style>
+        <p:txBody>
+          <a:bodyPr rtlCol="0" anchor="ctr"/>
+          <a:lstStyle/>
+          <a:p>
+            <a:pPr algn="ctr"/>
+          </a:p>
+        </p:txBody>
+      </p:sp>
+      <p:sp>
+        <p:nvSpPr>
+          <p:cNvPr id="3" name="Rectangle 2"/>
+          <p:cNvSpPr/>
+          <p:nvPr/>
+        </p:nvSpPr>
+        <p:spPr>
+          <a:xfrm>
+            <a:off x="0" y="73152"/>
+            <a:ext cx="2560320" cy="411480"/>
+          </a:xfrm>
+          <a:prstGeom prst="rect">
+            <a:avLst/>
+          </a:prstGeom>
+          <a:solidFill>
+            <a:srgbClr val="1E1E1E"/>
+          </a:solidFill>
+          <a:ln>
+            <a:noFill/>
+          </a:ln>
+        </p:spPr>
+        <p:style>
+          <a:lnRef idx="1">
+            <a:schemeClr val="accent1"/>
+          </a:lnRef>
+          <a:fillRef idx="3">
+            <a:schemeClr val="accent1"/>
+          </a:fillRef>
+          <a:effectRef idx="2">
+            <a:schemeClr val="accent1"/>
+          </a:effectRef>
+          <a:fontRef idx="minor">
+            <a:schemeClr val="lt1"/>
+          </a:fontRef>
+        </p:style>
+        <p:txBody>
+          <a:bodyPr rtlCol="0" anchor="ctr"/>
+          <a:lstStyle/>
+          <a:p>
+            <a:pPr algn="ctr"/>
+          </a:p>
+        </p:txBody>
+      </p:sp>
+      <p:sp>
+        <p:nvSpPr>
+          <p:cNvPr id="4" name="TextBox 3"/>
+          <p:cNvSpPr txBox="1"/>
+          <p:nvPr/>
+        </p:nvSpPr>
+        <p:spPr>
+          <a:xfrm>
+            <a:off x="91440" y="73152"/>
+            <a:ext cx="2377440" cy="411480"/>
+          </a:xfrm>
+          <a:prstGeom prst="rect">
+            <a:avLst/>
+          </a:prstGeom>
+          <a:noFill/>
+        </p:spPr>
+        <p:txBody>
+          <a:bodyPr wrap="square">
+            <a:spAutoFit/>
+          </a:bodyPr>
+          <a:lstStyle/>
+          <a:p>
+            <a:pPr algn="l"/>
+            <a:r>
+              <a:rPr sz="1100" b="0" i="0">
+                <a:solidFill>
+                  <a:srgbClr val="F5C518"/>
+                </a:solidFill>
+              </a:rPr>
+              <a:t>🎙  Văn Nguyễn</a:t>
+            </a:r>
+          </a:p>
+        </p:txBody>
+      </p:sp>
+      <p:sp>
+        <p:nvSpPr>
+          <p:cNvPr id="5" name="TextBox 4"/>
+          <p:cNvSpPr txBox="1"/>
+          <p:nvPr/>
+        </p:nvSpPr>
+        <p:spPr>
+          <a:xfrm>
+            <a:off x="457200" y="594360"/>
+            <a:ext cx="11247120" cy="685800"/>
+          </a:xfrm>
+          <a:prstGeom prst="rect">
+            <a:avLst/>
+          </a:prstGeom>
+          <a:noFill/>
+        </p:spPr>
+        <p:txBody>
+          <a:bodyPr wrap="square">
+            <a:spAutoFit/>
+          </a:bodyPr>
+          <a:lstStyle/>
+          <a:p>
+            <a:pPr algn="l"/>
+            <a:r>
+              <a:rPr sz="2800" b="1" i="0">
+                <a:solidFill>
+                  <a:srgbClr val="FFFFFF"/>
+                </a:solidFill>
+              </a:rPr>
+              <a:t>Slide 12 · Rate Limiting - Tường Lửa Chống Tấn Công</a:t>
+            </a:r>
+          </a:p>
+        </p:txBody>
+      </p:sp>
+      <p:sp>
+        <p:nvSpPr>
+          <p:cNvPr id="6" name="Rectangle 5"/>
+          <p:cNvSpPr/>
+          <p:nvPr/>
+        </p:nvSpPr>
+        <p:spPr>
+          <a:xfrm>
+            <a:off x="0" y="1325880"/>
+            <a:ext cx="12188952" cy="36576"/>
+          </a:xfrm>
+          <a:prstGeom prst="rect">
+            <a:avLst/>
+          </a:prstGeom>
+          <a:solidFill>
+            <a:srgbClr val="F5C518"/>
+          </a:solidFill>
+          <a:ln>
+            <a:noFill/>
+          </a:ln>
+        </p:spPr>
+        <p:style>
+          <a:lnRef idx="1">
+            <a:schemeClr val="accent1"/>
+          </a:lnRef>
+          <a:fillRef idx="3">
+            <a:schemeClr val="accent1"/>
+          </a:fillRef>
+          <a:effectRef idx="2">
+            <a:schemeClr val="accent1"/>
+          </a:effectRef>
+          <a:fontRef idx="minor">
+            <a:schemeClr val="lt1"/>
+          </a:fontRef>
+        </p:style>
+        <p:txBody>
+          <a:bodyPr rtlCol="0" anchor="ctr"/>
+          <a:lstStyle/>
+          <a:p>
+            <a:pPr algn="ctr"/>
+          </a:p>
+        </p:txBody>
+      </p:sp>
+      <p:sp>
+        <p:nvSpPr>
+          <p:cNvPr id="7" name="TextBox 6"/>
+          <p:cNvSpPr txBox="1"/>
+          <p:nvPr/>
+        </p:nvSpPr>
+        <p:spPr>
+          <a:xfrm>
+            <a:off x="457200" y="1463040"/>
+            <a:ext cx="10972800" cy="365760"/>
+          </a:xfrm>
+          <a:prstGeom prst="rect">
+            <a:avLst/>
+          </a:prstGeom>
+          <a:noFill/>
+        </p:spPr>
+        <p:txBody>
+          <a:bodyPr wrap="square">
+            <a:spAutoFit/>
+          </a:bodyPr>
+          <a:lstStyle/>
+          <a:p>
+            <a:pPr algn="l"/>
+            <a:r>
+              <a:rPr sz="1500" b="1" i="0">
+                <a:solidFill>
+                  <a:srgbClr val="F5C518"/>
+                </a:solidFill>
+              </a:rPr>
+              <a:t>Nguy cơ: API công khai → Dễ bị DDoS (tấn công làm nghẽn Server)</a:t>
+            </a:r>
+          </a:p>
+        </p:txBody>
+      </p:sp>
+      <p:sp>
+        <p:nvSpPr>
+          <p:cNvPr id="8" name="TextBox 7"/>
+          <p:cNvSpPr txBox="1"/>
+          <p:nvPr/>
+        </p:nvSpPr>
+        <p:spPr>
+          <a:xfrm>
+            <a:off x="457200" y="1920240"/>
+            <a:ext cx="10972800" cy="365760"/>
+          </a:xfrm>
+          <a:prstGeom prst="rect">
+            <a:avLst/>
+          </a:prstGeom>
+          <a:noFill/>
+        </p:spPr>
+        <p:txBody>
+          <a:bodyPr wrap="square">
+            <a:spAutoFit/>
+          </a:bodyPr>
+          <a:lstStyle/>
+          <a:p>
+            <a:pPr algn="l"/>
+            <a:r>
+              <a:rPr sz="1500" b="1" i="0">
+                <a:solidFill>
+                  <a:srgbClr val="F5C518"/>
+                </a:solidFill>
+              </a:rPr>
+              <a:t>Giải pháp: Fixed Window Rate Limiting Middleware</a:t>
+            </a:r>
+          </a:p>
+        </p:txBody>
+      </p:sp>
+      <p:sp>
+        <p:nvSpPr>
+          <p:cNvPr id="9" name="Rectangle 8"/>
+          <p:cNvSpPr/>
+          <p:nvPr/>
+        </p:nvSpPr>
+        <p:spPr>
+          <a:xfrm>
+            <a:off x="457200" y="2377440"/>
+            <a:ext cx="5029200" cy="2011680"/>
+          </a:xfrm>
+          <a:prstGeom prst="rect">
+            <a:avLst/>
+          </a:prstGeom>
+          <a:solidFill>
+            <a:srgbClr val="1A2A1A"/>
+          </a:solidFill>
+          <a:ln>
+            <a:noFill/>
+          </a:ln>
+        </p:spPr>
+        <p:style>
+          <a:lnRef idx="1">
+            <a:schemeClr val="accent1"/>
+          </a:lnRef>
+          <a:fillRef idx="3">
+            <a:schemeClr val="accent1"/>
+          </a:fillRef>
+          <a:effectRef idx="2">
+            <a:schemeClr val="accent1"/>
+          </a:effectRef>
+          <a:fontRef idx="minor">
+            <a:schemeClr val="lt1"/>
+          </a:fontRef>
+        </p:style>
+        <p:txBody>
+          <a:bodyPr rtlCol="0" anchor="ctr"/>
+          <a:lstStyle/>
+          <a:p>
+            <a:pPr algn="ctr"/>
+          </a:p>
+        </p:txBody>
+      </p:sp>
+      <p:sp>
+        <p:nvSpPr>
+          <p:cNvPr id="10" name="TextBox 9"/>
+          <p:cNvSpPr txBox="1"/>
+          <p:nvPr/>
+        </p:nvSpPr>
+        <p:spPr>
+          <a:xfrm>
+            <a:off x="594360" y="2423160"/>
+            <a:ext cx="4572000" cy="320040"/>
+          </a:xfrm>
+          <a:prstGeom prst="rect">
+            <a:avLst/>
+          </a:prstGeom>
+          <a:noFill/>
+        </p:spPr>
+        <p:txBody>
+          <a:bodyPr wrap="square">
+            <a:spAutoFit/>
+          </a:bodyPr>
+          <a:lstStyle/>
+          <a:p>
+            <a:pPr algn="l"/>
+            <a:r>
+              <a:rPr sz="1300" b="1" i="0">
+                <a:solidFill>
+                  <a:srgbClr val="86EFAC"/>
+                </a:solidFill>
+              </a:rPr>
+              <a:t>Cấu hình hiện tại:</a:t>
+            </a:r>
+          </a:p>
+        </p:txBody>
+      </p:sp>
+      <p:sp>
+        <p:nvSpPr>
+          <p:cNvPr id="11" name="TextBox 10"/>
+          <p:cNvSpPr txBox="1"/>
+          <p:nvPr/>
+        </p:nvSpPr>
+        <p:spPr>
+          <a:xfrm>
+            <a:off x="594360" y="2788920"/>
+            <a:ext cx="4663440" cy="1371600"/>
+          </a:xfrm>
+          <a:prstGeom prst="rect">
+            <a:avLst/>
+          </a:prstGeom>
+          <a:noFill/>
+        </p:spPr>
+        <p:txBody>
+          <a:bodyPr wrap="square">
+            <a:spAutoFit/>
+          </a:bodyPr>
+          <a:lstStyle/>
+          <a:p>
+            <a:pPr algn="l"/>
+            <a:r>
+              <a:rPr sz="1400" b="0" i="0">
+                <a:solidFill>
+                  <a:srgbClr val="FFFFFF"/>
+                </a:solidFill>
+              </a:rPr>
+              <a:t>• Permit Limit: 5 Request
+• Window: 10 giây / IP
+• Queue: 2 Request được xếp hàng</a:t>
+            </a:r>
+          </a:p>
+        </p:txBody>
+      </p:sp>
+      <p:sp>
+        <p:nvSpPr>
+          <p:cNvPr id="12" name="Rectangle 11"/>
+          <p:cNvSpPr/>
+          <p:nvPr/>
+        </p:nvSpPr>
+        <p:spPr>
+          <a:xfrm>
+            <a:off x="5669280" y="2377440"/>
+            <a:ext cx="6035040" cy="2011680"/>
+          </a:xfrm>
+          <a:prstGeom prst="rect">
+            <a:avLst/>
+          </a:prstGeom>
+          <a:solidFill>
+            <a:srgbClr val="2A1A1A"/>
+          </a:solidFill>
+          <a:ln>
+            <a:noFill/>
+          </a:ln>
+        </p:spPr>
+        <p:style>
+          <a:lnRef idx="1">
+            <a:schemeClr val="accent1"/>
+          </a:lnRef>
+          <a:fillRef idx="3">
+            <a:schemeClr val="accent1"/>
+          </a:fillRef>
+          <a:effectRef idx="2">
+            <a:schemeClr val="accent1"/>
+          </a:effectRef>
+          <a:fontRef idx="minor">
+            <a:schemeClr val="lt1"/>
+          </a:fontRef>
+        </p:style>
+        <p:txBody>
+          <a:bodyPr rtlCol="0" anchor="ctr"/>
+          <a:lstStyle/>
+          <a:p>
+            <a:pPr algn="ctr"/>
+          </a:p>
+        </p:txBody>
+      </p:sp>
+      <p:sp>
+        <p:nvSpPr>
+          <p:cNvPr id="13" name="TextBox 12"/>
+          <p:cNvSpPr txBox="1"/>
+          <p:nvPr/>
+        </p:nvSpPr>
+        <p:spPr>
+          <a:xfrm>
+            <a:off x="5806440" y="2423160"/>
+            <a:ext cx="5669280" cy="320040"/>
+          </a:xfrm>
+          <a:prstGeom prst="rect">
+            <a:avLst/>
+          </a:prstGeom>
+          <a:noFill/>
+        </p:spPr>
+        <p:txBody>
+          <a:bodyPr wrap="square">
+            <a:spAutoFit/>
+          </a:bodyPr>
+          <a:lstStyle/>
+          <a:p>
+            <a:pPr algn="l"/>
+            <a:r>
+              <a:rPr sz="1300" b="1" i="0">
+                <a:solidFill>
+                  <a:srgbClr val="F87171"/>
+                </a:solidFill>
+              </a:rPr>
+              <a:t>Kết quả khi vượt giới hạn:</a:t>
+            </a:r>
+          </a:p>
+        </p:txBody>
+      </p:sp>
+      <p:sp>
+        <p:nvSpPr>
+          <p:cNvPr id="14" name="TextBox 13"/>
+          <p:cNvSpPr txBox="1"/>
+          <p:nvPr/>
+        </p:nvSpPr>
+        <p:spPr>
+          <a:xfrm>
+            <a:off x="5806440" y="2788920"/>
+            <a:ext cx="5669280" cy="1371600"/>
+          </a:xfrm>
+          <a:prstGeom prst="rect">
+            <a:avLst/>
+          </a:prstGeom>
+          <a:noFill/>
+        </p:spPr>
+        <p:txBody>
+          <a:bodyPr wrap="square">
+            <a:spAutoFit/>
+          </a:bodyPr>
+          <a:lstStyle/>
+          <a:p>
+            <a:pPr algn="l"/>
+            <a:r>
+              <a:rPr sz="1300" b="0" i="0">
+                <a:solidFill>
+                  <a:srgbClr val="FFFFFF"/>
+                </a:solidFill>
+              </a:rPr>
+              <a:t>❌  HTTP 429 Too Many Requests
+⚡  Bị chặn tại tầng HTTP Pipeline
+     → Chưa chạm vào AI Model
+     → CPU &amp; RAM hoàn toàn an toàn</a:t>
+            </a:r>
+          </a:p>
+        </p:txBody>
+      </p:sp>
+      <p:sp>
+        <p:nvSpPr>
+          <p:cNvPr id="15" name="Rectangle 14"/>
+          <p:cNvSpPr/>
+          <p:nvPr/>
+        </p:nvSpPr>
+        <p:spPr>
+          <a:xfrm>
+            <a:off x="457200" y="4937760"/>
+            <a:ext cx="11247120" cy="685800"/>
+          </a:xfrm>
+          <a:prstGeom prst="rect">
+            <a:avLst/>
+          </a:prstGeom>
+          <a:solidFill>
+            <a:srgbClr val="1B1B2A"/>
+          </a:solidFill>
+          <a:ln>
+            <a:noFill/>
+          </a:ln>
+        </p:spPr>
+        <p:style>
+          <a:lnRef idx="1">
+            <a:schemeClr val="accent1"/>
+          </a:lnRef>
+          <a:fillRef idx="3">
+            <a:schemeClr val="accent1"/>
+          </a:fillRef>
+          <a:effectRef idx="2">
+            <a:schemeClr val="accent1"/>
+          </a:effectRef>
+          <a:fontRef idx="minor">
+            <a:schemeClr val="lt1"/>
+          </a:fontRef>
+        </p:style>
+        <p:txBody>
+          <a:bodyPr rtlCol="0" anchor="ctr"/>
+          <a:lstStyle/>
+          <a:p>
+            <a:pPr algn="ctr"/>
+          </a:p>
+        </p:txBody>
+      </p:sp>
+      <p:sp>
+        <p:nvSpPr>
+          <p:cNvPr id="16" name="TextBox 15"/>
+          <p:cNvSpPr txBox="1"/>
+          <p:nvPr/>
+        </p:nvSpPr>
+        <p:spPr>
+          <a:xfrm>
+            <a:off x="640080" y="4983480"/>
+            <a:ext cx="10972800" cy="594360"/>
+          </a:xfrm>
+          <a:prstGeom prst="rect">
+            <a:avLst/>
+          </a:prstGeom>
+          <a:noFill/>
+        </p:spPr>
+        <p:txBody>
+          <a:bodyPr wrap="square">
+            <a:spAutoFit/>
+          </a:bodyPr>
+          <a:lstStyle/>
+          <a:p>
+            <a:pPr algn="l"/>
+            <a:r>
+              <a:rPr sz="1400" b="0" i="1">
+                <a:solidFill>
+                  <a:srgbClr val="3B82F6"/>
+                </a:solidFill>
+              </a:rPr>
+              <a:t>💡  Middleware chặn từ ngoài vào — lớp khiên thép bảo vệ toàn bộ tài nguyên phía trong.</a:t>
+            </a:r>
+          </a:p>
+        </p:txBody>
+      </p:sp>
+    </p:spTree>
+  </p:cSld>
+  <p:clrMapOvr>
+    <a:masterClrMapping/>
+  </p:clrMapOvr>
+</p:sld>
+</file>
+
+<file path=ppt/slides/slide17.xml><?xml version="1.0" encoding="utf-8"?>
+<p:sld xmlns:a="http://schemas.openxmlformats.org/drawingml/2006/main" xmlns:p="http://schemas.openxmlformats.org/presentationml/2006/main" xmlns:r="http://schemas.openxmlformats.org/officeDocument/2006/relationships">
+  <p:cSld>
+    <p:bg>
+      <p:bgPr>
+        <a:solidFill>
+          <a:srgbClr val="0D0D0D"/>
+        </a:solidFill>
+        <a:effectLst/>
+      </p:bgPr>
+    </p:bg>
+    <p:spTree>
+      <p:nvGrpSpPr>
+        <p:cNvPr id="1" name=""/>
+        <p:cNvGrpSpPr/>
+        <p:nvPr/>
+      </p:nvGrpSpPr>
+      <p:grpSpPr/>
+      <p:sp>
+        <p:nvSpPr>
+          <p:cNvPr id="2" name="Rectangle 1"/>
+          <p:cNvSpPr/>
+          <p:nvPr/>
+        </p:nvSpPr>
+        <p:spPr>
+          <a:xfrm>
+            <a:off x="0" y="0"/>
+            <a:ext cx="12188952" cy="109728"/>
+          </a:xfrm>
+          <a:prstGeom prst="rect">
+            <a:avLst/>
+          </a:prstGeom>
+          <a:solidFill>
+            <a:srgbClr val="F5C518"/>
+          </a:solidFill>
+          <a:ln>
+            <a:noFill/>
+          </a:ln>
+        </p:spPr>
+        <p:style>
+          <a:lnRef idx="1">
+            <a:schemeClr val="accent1"/>
+          </a:lnRef>
+          <a:fillRef idx="3">
+            <a:schemeClr val="accent1"/>
+          </a:fillRef>
+          <a:effectRef idx="2">
+            <a:schemeClr val="accent1"/>
+          </a:effectRef>
+          <a:fontRef idx="minor">
+            <a:schemeClr val="lt1"/>
+          </a:fontRef>
+        </p:style>
+        <p:txBody>
+          <a:bodyPr rtlCol="0" anchor="ctr"/>
+          <a:lstStyle/>
+          <a:p>
+            <a:pPr algn="ctr"/>
+          </a:p>
+        </p:txBody>
+      </p:sp>
+      <p:sp>
+        <p:nvSpPr>
+          <p:cNvPr id="3" name="Rectangle 2"/>
+          <p:cNvSpPr/>
+          <p:nvPr/>
+        </p:nvSpPr>
+        <p:spPr>
+          <a:xfrm>
+            <a:off x="0" y="6748272"/>
+            <a:ext cx="12188952" cy="109728"/>
+          </a:xfrm>
+          <a:prstGeom prst="rect">
+            <a:avLst/>
+          </a:prstGeom>
+          <a:solidFill>
+            <a:srgbClr val="F5C518"/>
+          </a:solidFill>
+          <a:ln>
+            <a:noFill/>
+          </a:ln>
+        </p:spPr>
+        <p:style>
+          <a:lnRef idx="1">
+            <a:schemeClr val="accent1"/>
+          </a:lnRef>
+          <a:fillRef idx="3">
+            <a:schemeClr val="accent1"/>
+          </a:fillRef>
+          <a:effectRef idx="2">
+            <a:schemeClr val="accent1"/>
+          </a:effectRef>
+          <a:fontRef idx="minor">
+            <a:schemeClr val="lt1"/>
+          </a:fontRef>
+        </p:style>
+        <p:txBody>
+          <a:bodyPr rtlCol="0" anchor="ctr"/>
+          <a:lstStyle/>
+          <a:p>
+            <a:pPr algn="ctr"/>
+          </a:p>
+        </p:txBody>
+      </p:sp>
+      <p:sp>
+        <p:nvSpPr>
+          <p:cNvPr id="4" name="TextBox 3"/>
+          <p:cNvSpPr txBox="1"/>
+          <p:nvPr/>
+        </p:nvSpPr>
+        <p:spPr>
+          <a:xfrm>
+            <a:off x="914400" y="914400"/>
+            <a:ext cx="10058400" cy="1097280"/>
+          </a:xfrm>
+          <a:prstGeom prst="rect">
+            <a:avLst/>
+          </a:prstGeom>
+          <a:noFill/>
+        </p:spPr>
+        <p:txBody>
+          <a:bodyPr wrap="square">
+            <a:spAutoFit/>
+          </a:bodyPr>
+          <a:lstStyle/>
+          <a:p>
+            <a:pPr algn="ctr"/>
+            <a:r>
+              <a:rPr sz="4400" b="1" i="0">
+                <a:solidFill>
+                  <a:srgbClr val="F5C518"/>
+                </a:solidFill>
+              </a:rPr>
+              <a:t>CẢM ƠN THẦY CÔ &amp; HỘI ĐỒNG!</a:t>
+            </a:r>
+          </a:p>
+        </p:txBody>
+      </p:sp>
+      <p:sp>
+        <p:nvSpPr>
+          <p:cNvPr id="5" name="TextBox 4"/>
+          <p:cNvSpPr txBox="1"/>
+          <p:nvPr/>
+        </p:nvSpPr>
+        <p:spPr>
+          <a:xfrm>
+            <a:off x="914400" y="2103120"/>
+            <a:ext cx="10058400" cy="548640"/>
+          </a:xfrm>
+          <a:prstGeom prst="rect">
+            <a:avLst/>
+          </a:prstGeom>
+          <a:noFill/>
+        </p:spPr>
+        <p:txBody>
+          <a:bodyPr wrap="square">
+            <a:spAutoFit/>
+          </a:bodyPr>
+          <a:lstStyle/>
+          <a:p>
+            <a:pPr algn="ctr"/>
+            <a:r>
+              <a:rPr sz="1800" b="0" i="1">
+                <a:solidFill>
+                  <a:srgbClr val="CCCCCC"/>
+                </a:solidFill>
+              </a:rPr>
+              <a:t>Nhóm 3 xin lắng nghe câu hỏi phản biện.</a:t>
+            </a:r>
+          </a:p>
+        </p:txBody>
+      </p:sp>
+      <p:sp>
+        <p:nvSpPr>
+          <p:cNvPr id="6" name="Rectangle 5"/>
+          <p:cNvSpPr/>
+          <p:nvPr/>
+        </p:nvSpPr>
+        <p:spPr>
+          <a:xfrm>
+            <a:off x="0" y="2834640"/>
+            <a:ext cx="12188952" cy="36576"/>
+          </a:xfrm>
+          <a:prstGeom prst="rect">
+            <a:avLst/>
+          </a:prstGeom>
+          <a:solidFill>
+            <a:srgbClr val="F5C518"/>
+          </a:solidFill>
+          <a:ln>
+            <a:noFill/>
+          </a:ln>
+        </p:spPr>
+        <p:style>
+          <a:lnRef idx="1">
+            <a:schemeClr val="accent1"/>
+          </a:lnRef>
+          <a:fillRef idx="3">
+            <a:schemeClr val="accent1"/>
+          </a:fillRef>
+          <a:effectRef idx="2">
+            <a:schemeClr val="accent1"/>
+          </a:effectRef>
+          <a:fontRef idx="minor">
+            <a:schemeClr val="lt1"/>
+          </a:fontRef>
+        </p:style>
+        <p:txBody>
+          <a:bodyPr rtlCol="0" anchor="ctr"/>
+          <a:lstStyle/>
+          <a:p>
+            <a:pPr algn="ctr"/>
+          </a:p>
+        </p:txBody>
+      </p:sp>
+      <p:sp>
+        <p:nvSpPr>
           <p:cNvPr id="7" name="Rectangle 6"/>
           <p:cNvSpPr/>
           <p:nvPr/>
@@ -7072,7 +8653,7 @@
                   <a:srgbClr val="FFFFFF"/>
                 </a:solidFill>
               </a:rPr>
-              <a:t>Văn Nguyễn</a:t>
+              <a:t>Thành Trung</a:t>
             </a:r>
           </a:p>
         </p:txBody>
@@ -7106,7 +8687,7 @@
                   <a:srgbClr val="CCCCCC"/>
                 </a:solidFill>
               </a:rPr>
-              <a:t>Hiệu năng &amp; Bảo mật</a:t>
+              <a:t>DevOps &amp; Live Demo</a:t>
             </a:r>
           </a:p>
         </p:txBody>
@@ -7226,7 +8807,7 @@
                   <a:srgbClr val="FFFFFF"/>
                 </a:solidFill>
               </a:rPr>
-              <a:t>Thành Trung</a:t>
+              <a:t>Văn Nguyễn</a:t>
             </a:r>
           </a:p>
         </p:txBody>
@@ -7260,7 +8841,7 @@
                   <a:srgbClr val="CCCCCC"/>
                 </a:solidFill>
               </a:rPr>
-              <a:t>DevOps &amp; Live Demo</a:t>
+              <a:t>Hiệu năng &amp; Bảo mật</a:t>
             </a:r>
           </a:p>
         </p:txBody>

</xml_diff>

<commit_message>
feat: complete Vietnamese translations with correct diacritics using Unicode hex
</commit_message>
<xml_diff>
--- a/X-AURUM_Presentation.pptx
+++ b/X-AURUM_Presentation.pptx
@@ -3258,7 +3258,7 @@
                   <a:srgbClr val="FFFFFF"/>
                 </a:solidFill>
               </a:rPr>
-              <a:t>He Thong Du Bao Gia Vang Theo Thoi Gian Thuc</a:t>
+              <a:t>Hệ Thống Dự Báo Giá Vàng Theo Thời Gian Thực</a:t>
             </a:r>
           </a:p>
         </p:txBody>
@@ -3292,7 +3292,7 @@
                   <a:srgbClr val="CCCCCC"/>
                 </a:solidFill>
               </a:rPr>
-              <a:t>Trien khai Web API tich hop Tri tue Nhan tao &amp; Du lieu Thi truong Toan cau</a:t>
+              <a:t>Triển khai Web API tích hợp Trí tuệ Nhân tạo &amp; Dữ liệu Thị trường Toàn cầu</a:t>
             </a:r>
           </a:p>
         </p:txBody>
@@ -3369,7 +3369,7 @@
                   <a:srgbClr val="CCCCCC"/>
                 </a:solidFill>
               </a:rPr>
-              <a:t>Nhom 3  |  Xuan Huong  |  Quoc Dat  |  Van Nguyen  |  Thanh Trung</a:t>
+              <a:t>Nhóm 3  |  Xuân Hương  |  Quốc Đạt  |  Văn Nguyễn  |  Thành Trung</a:t>
             </a:r>
           </a:p>
         </p:txBody>
@@ -3549,7 +3549,7 @@
                   <a:srgbClr val="F5C518"/>
                 </a:solidFill>
               </a:rPr>
-              <a:t>  Van Nguyen</a:t>
+              <a:t>  Văn Nguyễn</a:t>
             </a:r>
           </a:p>
         </p:txBody>
@@ -3583,7 +3583,7 @@
                   <a:srgbClr val="FFFFFF"/>
                 </a:solidFill>
               </a:rPr>
-              <a:t>Slide 9 - Rate Limiting - Tuong Lua Chong Tan Cong</a:t>
+              <a:t>Slide 9 · Rate Limiting - Tường Lửa Chống Tấn Công</a:t>
             </a:r>
           </a:p>
         </p:txBody>
@@ -3660,7 +3660,7 @@
                   <a:srgbClr val="F5C518"/>
                 </a:solidFill>
               </a:rPr>
-              <a:t>Nguy co: API cong khai -&gt; De bi DDoS (tan cong lam nghen Server)</a:t>
+              <a:t>Nguy cơ: API công khai → Dễ bị DDoS (tấn công làm nghẽn Server)</a:t>
             </a:r>
           </a:p>
         </p:txBody>
@@ -3694,7 +3694,7 @@
                   <a:srgbClr val="F5C518"/>
                 </a:solidFill>
               </a:rPr>
-              <a:t>Giai phap: Fixed Window Rate Limiting Middleware</a:t>
+              <a:t>Giải pháp: Fixed Window Rate Limiting Middleware</a:t>
             </a:r>
           </a:p>
         </p:txBody>
@@ -3771,7 +3771,7 @@
                   <a:srgbClr val="86EFAC"/>
                 </a:solidFill>
               </a:rPr>
-              <a:t>Cau hinh hien tai:</a:t>
+              <a:t>Cấu hình hiện tại:</a:t>
             </a:r>
           </a:p>
         </p:txBody>
@@ -3806,8 +3806,8 @@
                 </a:solidFill>
               </a:rPr>
               <a:t>  Permit Limit: 5 Request
-  Window: 10 giay / IP
-  Queue: 2 Request duoc xep hang</a:t>
+  Window: 10 giây / IP
+  Queue: 2 Request được xếp hàng</a:t>
             </a:r>
           </a:p>
         </p:txBody>
@@ -3884,7 +3884,7 @@
                   <a:srgbClr val="F87171"/>
                 </a:solidFill>
               </a:rPr>
-              <a:t>Ket qua khi vuot gioi han:</a:t>
+              <a:t>Kết quả khi vượt giới hạn:</a:t>
             </a:r>
           </a:p>
         </p:txBody>
@@ -3919,9 +3919,9 @@
                 </a:solidFill>
               </a:rPr>
               <a:t>  HTTP 429 Too Many Requests
-  Bi chan tai tang HTTP Pipeline
-  -&gt; Chua cham vao AI Model
-  -&gt; CPU &amp; RAM hoan toan an toan</a:t>
+  Bị chặn tại tầng HTTP Pipeline
+  → Chưa chạm vào AI Model
+  → CPU &amp; RAM hoàn toàn an toàn</a:t>
             </a:r>
           </a:p>
         </p:txBody>
@@ -3998,7 +3998,7 @@
                   <a:srgbClr val="3B82F6"/>
                 </a:solidFill>
               </a:rPr>
-              <a:t>Middleware chan tu ngoai vao — lop khien thep bao ve toan bo tai nguyen phia trong.</a:t>
+              <a:t>Middleware chặn từ ngoài vào — lớp khiên thép bảo vệ toàn bộ tài nguyên phía trong.</a:t>
             </a:r>
           </a:p>
         </p:txBody>
@@ -4144,7 +4144,7 @@
                   <a:srgbClr val="F5C518"/>
                 </a:solidFill>
               </a:rPr>
-              <a:t>  Thanh Trung</a:t>
+              <a:t>  Thành Trung</a:t>
             </a:r>
           </a:p>
         </p:txBody>
@@ -4178,7 +4178,7 @@
                   <a:srgbClr val="FFFFFF"/>
                 </a:solidFill>
               </a:rPr>
-              <a:t>Slide 10 - Docker - Dong Goi &amp; Chuan Hoa Moi Truong</a:t>
+              <a:t>Slide 10 · Docker - Đóng Gói &amp; Chuẩn Hóa Môi Trường</a:t>
             </a:r>
           </a:p>
         </p:txBody>
@@ -4255,7 +4255,7 @@
                   <a:srgbClr val="F5C518"/>
                 </a:solidFill>
               </a:rPr>
-              <a:t>Van de: 'Code chay may em, sao Server lai loi?' -&gt; Xung dot moi truong .NET</a:t>
+              <a:t>Vấn đề: 'Code chạy máy em, sao Server lại lỗi?' → Xung đột môi trường .NET</a:t>
             </a:r>
           </a:p>
         </p:txBody>
@@ -4289,7 +4289,7 @@
                   <a:srgbClr val="F5C518"/>
                 </a:solidFill>
               </a:rPr>
-              <a:t>Giai phap: Docker Multi-stage Build</a:t>
+              <a:t>Giải pháp: Docker Multi-stage Build</a:t>
             </a:r>
           </a:p>
         </p:txBody>
@@ -4406,7 +4406,7 @@
                   <a:srgbClr val="F5C518"/>
                 </a:solidFill>
               </a:rPr>
-              <a:t>Ket qua:</a:t>
+              <a:t>Kết quả:</a:t>
             </a:r>
           </a:p>
         </p:txBody>
@@ -4440,7 +4440,7 @@
                   <a:srgbClr val="CCCCCC"/>
                 </a:solidFill>
               </a:rPr>
-              <a:t>  *  Image production chi ~200MB.</a:t>
+              <a:t>  •  Image production chỉ ~200MB.</a:t>
             </a:r>
           </a:p>
         </p:txBody>
@@ -4474,7 +4474,7 @@
                   <a:srgbClr val="CCCCCC"/>
                 </a:solidFill>
               </a:rPr>
-              <a:t>  *  Khong chua SDK thua.</a:t>
+              <a:t>  •  Không chứa SDK thừa.</a:t>
             </a:r>
           </a:p>
         </p:txBody>
@@ -4508,7 +4508,7 @@
                   <a:srgbClr val="CCCCCC"/>
                 </a:solidFill>
               </a:rPr>
-              <a:t>  *  Chay giong het nhau tren moi may co Docker.</a:t>
+              <a:t>  •  Chạy giống hệt nhau trên mọi máy có Docker.</a:t>
             </a:r>
           </a:p>
         </p:txBody>
@@ -4542,7 +4542,7 @@
                   <a:srgbClr val="CCCCCC"/>
                 </a:solidFill>
               </a:rPr>
-              <a:t>  *  </a:t>
+              <a:t>  •  </a:t>
             </a:r>
           </a:p>
         </p:txBody>
@@ -4576,7 +4576,7 @@
                   <a:srgbClr val="CCCCCC"/>
                 </a:solidFill>
               </a:rPr>
-              <a:t>  *  docker compose up -d</a:t>
+              <a:t>  •  docker compose up -d</a:t>
             </a:r>
           </a:p>
         </p:txBody>
@@ -4610,7 +4610,7 @@
                   <a:srgbClr val="CCCCCC"/>
                 </a:solidFill>
               </a:rPr>
-              <a:t>  *  -&gt; Toan bo he thong khoi dong</a:t>
+              <a:t>  •  → Toàn bộ hệ thống khởi động</a:t>
             </a:r>
           </a:p>
         </p:txBody>
@@ -4644,7 +4644,7 @@
                   <a:srgbClr val="CCCCCC"/>
                 </a:solidFill>
               </a:rPr>
-              <a:t>  *  chi voi 1 lenh duy nhat.</a:t>
+              <a:t>  •  chỉ với 1 lệnh duy nhất.</a:t>
             </a:r>
           </a:p>
         </p:txBody>
@@ -4790,7 +4790,7 @@
                   <a:srgbClr val="F5C518"/>
                 </a:solidFill>
               </a:rPr>
-              <a:t>  Thanh Trung</a:t>
+              <a:t>  Thành Trung</a:t>
             </a:r>
           </a:p>
         </p:txBody>
@@ -4824,7 +4824,7 @@
                   <a:srgbClr val="FFFFFF"/>
                 </a:solidFill>
               </a:rPr>
-              <a:t>Slide 11 - CI/CD &amp; Trien Khai Tren nttspace.online</a:t>
+              <a:t>Slide 11 · CI/CD &amp; Triển Khai Trên nttspace.online</a:t>
             </a:r>
           </a:p>
         </p:txBody>
@@ -4901,7 +4901,7 @@
                   <a:srgbClr val="F5C518"/>
                 </a:solidFill>
               </a:rPr>
-              <a:t>Quy trinh CI/CD tu dong (GitHub Actions):</a:t>
+              <a:t>Quy trình CI/CD tự động (GitHub Actions):</a:t>
             </a:r>
           </a:p>
         </p:txBody>
@@ -4978,7 +4978,7 @@
                   <a:srgbClr val="F5C518"/>
                 </a:solidFill>
               </a:rPr>
-              <a:t> [PUSH] git push len GitHub</a:t>
+              <a:t>  [&gt;&gt;] git push lên GitHub</a:t>
             </a:r>
           </a:p>
         </p:txBody>
@@ -5055,7 +5055,7 @@
                   <a:srgbClr val="CCCCCC"/>
                 </a:solidFill>
               </a:rPr>
-              <a:t> &gt;&gt; GitHub Actions kich hoat</a:t>
+              <a:t>  &gt;&gt; GitHub Actions kích hoạt</a:t>
             </a:r>
           </a:p>
         </p:txBody>
@@ -5132,7 +5132,7 @@
                   <a:srgbClr val="CCCCCC"/>
                 </a:solidFill>
               </a:rPr>
-              <a:t> &gt;&gt; Build Docker Image</a:t>
+              <a:t>  &gt;&gt; Build Docker Image</a:t>
             </a:r>
           </a:p>
         </p:txBody>
@@ -5209,7 +5209,7 @@
                   <a:srgbClr val="CCCCCC"/>
                 </a:solidFill>
               </a:rPr>
-              <a:t> &gt;&gt; Push len GHCR (GitHub Container Registry)</a:t>
+              <a:t>  &gt;&gt; Push lên GHCR (GitHub Container Registry)</a:t>
             </a:r>
           </a:p>
         </p:txBody>
@@ -5286,7 +5286,7 @@
                   <a:srgbClr val="86EFAC"/>
                 </a:solidFill>
               </a:rPr>
-              <a:t> &gt;&gt; Server keo image moi &amp; Restart</a:t>
+              <a:t>  &gt;&gt; Server kéo image mới &amp; Restart</a:t>
             </a:r>
           </a:p>
         </p:txBody>
@@ -5354,7 +5354,7 @@
                   <a:srgbClr val="CCCCCC"/>
                 </a:solidFill>
               </a:rPr>
-              <a:t>  *  Tiep nhan traffic tu nttspace.online</a:t>
+              <a:t>  •  Tiếp nhận traffic từ nttspace.online</a:t>
             </a:r>
           </a:p>
         </p:txBody>
@@ -5388,7 +5388,7 @@
                   <a:srgbClr val="CCCCCC"/>
                 </a:solidFill>
               </a:rPr>
-              <a:t>  *  (Port 80 / 443 HTTPS).</a:t>
+              <a:t>  •  (Port 80 / 443 HTTPS).</a:t>
             </a:r>
           </a:p>
         </p:txBody>
@@ -5422,7 +5422,7 @@
                   <a:srgbClr val="CCCCCC"/>
                 </a:solidFill>
               </a:rPr>
-              <a:t>  *  </a:t>
+              <a:t>  •  </a:t>
             </a:r>
           </a:p>
         </p:txBody>
@@ -5456,7 +5456,7 @@
                   <a:srgbClr val="CCCCCC"/>
                 </a:solidFill>
               </a:rPr>
-              <a:t>  *  Chuyen tiep vao Docker Container</a:t>
+              <a:t>  •  Chuyển tiếp vào Docker Container</a:t>
             </a:r>
           </a:p>
         </p:txBody>
@@ -5490,7 +5490,7 @@
                   <a:srgbClr val="CCCCCC"/>
                 </a:solidFill>
               </a:rPr>
-              <a:t>  *  dang lang nghe noi bo.</a:t>
+              <a:t>  •  đang lắng nghe nội bộ.</a:t>
             </a:r>
           </a:p>
         </p:txBody>
@@ -5524,7 +5524,7 @@
                   <a:srgbClr val="CCCCCC"/>
                 </a:solidFill>
               </a:rPr>
-              <a:t>  *  </a:t>
+              <a:t>  •  </a:t>
             </a:r>
           </a:p>
         </p:txBody>
@@ -5558,7 +5558,7 @@
                   <a:srgbClr val="CCCCCC"/>
                 </a:solidFill>
               </a:rPr>
-              <a:t>  *  Ket qua:</a:t>
+              <a:t>  •  Kết quả:</a:t>
             </a:r>
           </a:p>
         </p:txBody>
@@ -5781,7 +5781,7 @@
                   <a:srgbClr val="F5C518"/>
                 </a:solidFill>
               </a:rPr>
-              <a:t>  Thanh Trung</a:t>
+              <a:t>  Thành Trung</a:t>
             </a:r>
           </a:p>
         </p:txBody>
@@ -5815,7 +5815,7 @@
                   <a:srgbClr val="FFFFFF"/>
                 </a:solidFill>
               </a:rPr>
-              <a:t>Slide 12 - Live Demo Tren Swagger</a:t>
+              <a:t>Slide 12 · Live Demo Trên Swagger</a:t>
             </a:r>
           </a:p>
         </p:txBody>
@@ -5892,7 +5892,7 @@
                   <a:srgbClr val="F5C518"/>
                 </a:solidFill>
               </a:rPr>
-              <a:t>Demo 1 -- GET /api/v1/predictions/realtime</a:t>
+              <a:t>Demo 1 — GET /api/v1/predictions/realtime</a:t>
             </a:r>
           </a:p>
         </p:txBody>
@@ -5926,7 +5926,7 @@
                   <a:srgbClr val="CCCCCC"/>
                 </a:solidFill>
               </a:rPr>
-              <a:t>  *  1. Mo Swagger UI tren nttspace.online</a:t>
+              <a:t>  •  1. Mở Swagger UI trên nttspace.online</a:t>
             </a:r>
           </a:p>
         </p:txBody>
@@ -5960,7 +5960,7 @@
                   <a:srgbClr val="CCCCCC"/>
                 </a:solidFill>
               </a:rPr>
-              <a:t>  *  2. Chon GET /realtime -&gt; Execute</a:t>
+              <a:t>  •  2. Chọn GET /realtime → Execute</a:t>
             </a:r>
           </a:p>
         </p:txBody>
@@ -5994,7 +5994,7 @@
                   <a:srgbClr val="CCCCCC"/>
                 </a:solidFill>
               </a:rPr>
-              <a:t>  *  3. Server tu goi Binance + Exchange Rates</a:t>
+              <a:t>  •  3. Server tự gọi Binance + Exchange Rates</a:t>
             </a:r>
           </a:p>
         </p:txBody>
@@ -6028,7 +6028,7 @@
                   <a:srgbClr val="CCCCCC"/>
                 </a:solidFill>
               </a:rPr>
-              <a:t>  *  4. AI tinh toan -&gt; Tra JSON:</a:t>
+              <a:t>  •  4. AI tính toán → Trả JSON:</a:t>
             </a:r>
           </a:p>
         </p:txBody>
@@ -6140,7 +6140,7 @@
                   <a:srgbClr val="F5C518"/>
                 </a:solidFill>
               </a:rPr>
-              <a:t>Demo 2 -- Kiem tra Rate Limiting</a:t>
+              <a:t>Demo 2 — Kiểm tra Rate Limiting</a:t>
             </a:r>
           </a:p>
         </p:txBody>
@@ -6174,7 +6174,7 @@
                   <a:srgbClr val="CCCCCC"/>
                 </a:solidFill>
               </a:rPr>
-              <a:t>  *  1. Chon POST /predictions -&gt; Execute lien tuc</a:t>
+              <a:t>  •  1. Chọn POST /predictions → Execute liên tục</a:t>
             </a:r>
           </a:p>
         </p:txBody>
@@ -6208,7 +6208,7 @@
                   <a:srgbClr val="CCCCCC"/>
                 </a:solidFill>
               </a:rPr>
-              <a:t>  *  2. Lan 1-5: Response 200 OK [OK]</a:t>
+              <a:t>  •  2. Lần 1-5: Response 200 OK</a:t>
             </a:r>
           </a:p>
         </p:txBody>
@@ -6242,7 +6242,7 @@
                   <a:srgbClr val="CCCCCC"/>
                 </a:solidFill>
               </a:rPr>
-              <a:t>  *  3. Lan 6-7: Response 429 [FAIL]</a:t>
+              <a:t>  •  3. Lần 6-7: Response 429 [!]</a:t>
             </a:r>
           </a:p>
         </p:txBody>
@@ -6276,7 +6276,7 @@
                   <a:srgbClr val="CCCCCC"/>
                 </a:solidFill>
               </a:rPr>
-              <a:t>  *  Too Many Requests</a:t>
+              <a:t>  •  Too Many Requests</a:t>
             </a:r>
           </a:p>
         </p:txBody>
@@ -6310,7 +6310,7 @@
                   <a:srgbClr val="CCCCCC"/>
                 </a:solidFill>
               </a:rPr>
-              <a:t>  *  -&gt; Tuong lua hoat dong hoan hao!</a:t>
+              <a:t>  •  → Tường lửa hoạt động hoàn hảo!</a:t>
             </a:r>
           </a:p>
         </p:txBody>
@@ -6387,7 +6387,7 @@
                   <a:srgbClr val="86EFAC"/>
                 </a:solidFill>
               </a:rPr>
-              <a:t>Toan bo he thong dang chay LIVE tai  nttspace.online</a:t>
+              <a:t>Toàn bộ hệ thống đang chạy LIVE tại  nttspace.online</a:t>
             </a:r>
           </a:p>
         </p:txBody>
@@ -6533,7 +6533,7 @@
                   <a:srgbClr val="F5C518"/>
                 </a:solidFill>
               </a:rPr>
-              <a:t>CAM ON THAY CO &amp; HOI DONG!</a:t>
+              <a:t>CẢM ƠN THẦY CÔ &amp; HỘI ĐỔNG!</a:t>
             </a:r>
           </a:p>
         </p:txBody>
@@ -6567,7 +6567,7 @@
                   <a:srgbClr val="CCCCCC"/>
                 </a:solidFill>
               </a:rPr>
-              <a:t>Nhom 3 xin lang nghe cau hoi phan bien.</a:t>
+              <a:t>Nhóm 3 xin lắng nghe câu hỏi phản biện.</a:t>
             </a:r>
           </a:p>
         </p:txBody>
@@ -6730,7 +6730,7 @@
                   <a:srgbClr val="FFFFFF"/>
                 </a:solidFill>
               </a:rPr>
-              <a:t>Xuan Huong</a:t>
+              <a:t>Xuân Hương</a:t>
             </a:r>
           </a:p>
         </p:txBody>
@@ -6764,7 +6764,7 @@
                   <a:srgbClr val="CCCCCC"/>
                 </a:solidFill>
               </a:rPr>
-              <a:t>Kien truc API &amp; Swagger</a:t>
+              <a:t>Kiến trúc API &amp; Swagger</a:t>
             </a:r>
           </a:p>
         </p:txBody>
@@ -6884,7 +6884,7 @@
                   <a:srgbClr val="FFFFFF"/>
                 </a:solidFill>
               </a:rPr>
-              <a:t>Quoc Dat</a:t>
+              <a:t>Quốc Đạt</a:t>
             </a:r>
           </a:p>
         </p:txBody>
@@ -6918,7 +6918,7 @@
                   <a:srgbClr val="CCCCCC"/>
                 </a:solidFill>
               </a:rPr>
-              <a:t>Tich hop 3rd-Party APIs</a:t>
+              <a:t>Tích hợp 3rd-Party APIs</a:t>
             </a:r>
           </a:p>
         </p:txBody>
@@ -7038,7 +7038,7 @@
                   <a:srgbClr val="FFFFFF"/>
                 </a:solidFill>
               </a:rPr>
-              <a:t>Van Nguyen</a:t>
+              <a:t>Văn Nguyễn</a:t>
             </a:r>
           </a:p>
         </p:txBody>
@@ -7072,7 +7072,7 @@
                   <a:srgbClr val="CCCCCC"/>
                 </a:solidFill>
               </a:rPr>
-              <a:t>Hieu nang &amp; Bao mat</a:t>
+              <a:t>Hiệu năng &amp; Bảo mật</a:t>
             </a:r>
           </a:p>
         </p:txBody>
@@ -7192,7 +7192,7 @@
                   <a:srgbClr val="FFFFFF"/>
                 </a:solidFill>
               </a:rPr>
-              <a:t>Thanh Trung</a:t>
+              <a:t>Thành Trung</a:t>
             </a:r>
           </a:p>
         </p:txBody>
@@ -7406,7 +7406,7 @@
                   <a:srgbClr val="F5C518"/>
                 </a:solidFill>
               </a:rPr>
-              <a:t>  Xuan Huong</a:t>
+              <a:t>  Xuân Hương</a:t>
             </a:r>
           </a:p>
         </p:txBody>
@@ -7440,7 +7440,7 @@
                   <a:srgbClr val="FFFFFF"/>
                 </a:solidFill>
               </a:rPr>
-              <a:t>Slide 1 - Bai Toan &amp; Kien Truc Cot Loi</a:t>
+              <a:t>Slide 1 · Bài Toán &amp; Kiến Trúc Cốt Lõi</a:t>
             </a:r>
           </a:p>
         </p:txBody>
@@ -7517,7 +7517,7 @@
                   <a:srgbClr val="F5C518"/>
                 </a:solidFill>
               </a:rPr>
-              <a:t>Van de dat ra</a:t>
+              <a:t>Vấn đề đặt ra</a:t>
             </a:r>
           </a:p>
         </p:txBody>
@@ -7551,7 +7551,7 @@
                   <a:srgbClr val="CCCCCC"/>
                 </a:solidFill>
               </a:rPr>
-              <a:t>  *  Mo hinh AI (ML.NET) chi chay duoc tren Console noi bo.</a:t>
+              <a:t>  •  Mô hình AI (ML.NET) chỉ chạy được trên Console nội bộ.</a:t>
             </a:r>
           </a:p>
         </p:txBody>
@@ -7585,7 +7585,7 @@
                   <a:srgbClr val="CCCCCC"/>
                 </a:solidFill>
               </a:rPr>
-              <a:t>  *  Khong the chia se hoac tai su dung tu ben ngoai.</a:t>
+              <a:t>  •  Không thể chia sẻ hoặc tái sử dụng từ bên ngoài.</a:t>
             </a:r>
           </a:p>
         </p:txBody>
@@ -7619,7 +7619,7 @@
                   <a:srgbClr val="F5C518"/>
                 </a:solidFill>
               </a:rPr>
-              <a:t>Giai phap: ASP.NET Core Minimal API (.NET 10)</a:t>
+              <a:t>Giải pháp: ASP.NET Core Minimal API (.NET 10)</a:t>
             </a:r>
           </a:p>
         </p:txBody>
@@ -7653,7 +7653,7 @@
                   <a:srgbClr val="CCCCCC"/>
                 </a:solidFill>
               </a:rPr>
-              <a:t>  *  Boc thuat toan AI thanh Web Service chuan HTTP.</a:t>
+              <a:t>  •  Bọc thuật toán AI thành Web Service chuẩn HTTP.</a:t>
             </a:r>
           </a:p>
         </p:txBody>
@@ -7687,7 +7687,7 @@
                   <a:srgbClr val="CCCCCC"/>
                 </a:solidFill>
               </a:rPr>
-              <a:t>  *  Loai bo Controllers truyen thong — Microservices tinh gon nhat.</a:t>
+              <a:t>  •  Loại bỏ Controllers truyền thống — kiến trúc Microservices tinh gọn nhất.</a:t>
             </a:r>
           </a:p>
         </p:txBody>
@@ -7947,7 +7947,7 @@
                   <a:srgbClr val="F5C518"/>
                 </a:solidFill>
               </a:rPr>
-              <a:t>  Xuan Huong</a:t>
+              <a:t>  Xuân Hương</a:t>
             </a:r>
           </a:p>
         </p:txBody>
@@ -7981,7 +7981,7 @@
                   <a:srgbClr val="FFFFFF"/>
                 </a:solidFill>
               </a:rPr>
-              <a:t>Slide 2 - Thiet Ke Hai Luong Endpoint</a:t>
+              <a:t>Slide 2 · Thiết Kế Hai Luồng Endpoint</a:t>
             </a:r>
           </a:p>
         </p:txBody>
@@ -8255,7 +8255,7 @@
                   <a:srgbClr val="0D0D0D"/>
                 </a:solidFill>
               </a:rPr>
-              <a:t>Mo ta</a:t>
+              <a:t>Mô tả</a:t>
             </a:r>
           </a:p>
         </p:txBody>
@@ -8486,7 +8486,7 @@
                   <a:srgbClr val="CCCCCC"/>
                 </a:solidFill>
               </a:rPr>
-              <a:t>Client tu nhap du lieu OHLCV</a:t>
+              <a:t>Client tự nhập dữ liệu OHLCV</a:t>
             </a:r>
           </a:p>
         </p:txBody>
@@ -8717,7 +8717,7 @@
                   <a:srgbClr val="CCCCCC"/>
                 </a:solidFill>
               </a:rPr>
-              <a:t>Bot tu keo data — khong can input</a:t>
+              <a:t>Bot tự kéo data — không cần input</a:t>
             </a:r>
           </a:p>
         </p:txBody>
@@ -8751,7 +8751,7 @@
                   <a:srgbClr val="F5C518"/>
                 </a:solidFill>
               </a:rPr>
-              <a:t>Chuan hoa Response RESTful (JSON Wrapper)</a:t>
+              <a:t>Chuẩn hóa Response RESTful (JSON Wrapper)</a:t>
             </a:r>
           </a:p>
         </p:txBody>
@@ -8869,7 +8869,7 @@
                   <a:srgbClr val="CCCCCC"/>
                 </a:solidFill>
               </a:rPr>
-              <a:t>  *  Moi Client deu parse an toan.</a:t>
+              <a:t>  •  Mọi Client đều parse an toàn.</a:t>
             </a:r>
           </a:p>
         </p:txBody>
@@ -8903,7 +8903,7 @@
                   <a:srgbClr val="CCCCCC"/>
                 </a:solidFill>
               </a:rPr>
-              <a:t>  *  De mo rong them truong moi.</a:t>
+              <a:t>  •  Dễ mở rộng thêm trường mới.</a:t>
             </a:r>
           </a:p>
         </p:txBody>
@@ -8937,7 +8937,7 @@
                   <a:srgbClr val="CCCCCC"/>
                 </a:solidFill>
               </a:rPr>
-              <a:t>  *  Phan biet ro luong Manual vs Auto.</a:t>
+              <a:t>  •  Phân biệt rõ luồng Manual vs Auto.</a:t>
             </a:r>
           </a:p>
         </p:txBody>
@@ -9083,7 +9083,7 @@
                   <a:srgbClr val="F5C518"/>
                 </a:solidFill>
               </a:rPr>
-              <a:t>  Xuan Huong</a:t>
+              <a:t>  Xuân Hương</a:t>
             </a:r>
           </a:p>
         </p:txBody>
@@ -9117,7 +9117,7 @@
                   <a:srgbClr val="FFFFFF"/>
                 </a:solidFill>
               </a:rPr>
-              <a:t>Slide 3 - Tai Lieu API Tu Dong Voi Swagger (OpenAPI)</a:t>
+              <a:t>Slide 3 · Tài Liệu API Tự Động Với Swagger (OpenAPI)</a:t>
             </a:r>
           </a:p>
         </p:txBody>
@@ -9194,7 +9194,7 @@
                   <a:srgbClr val="F5C518"/>
                 </a:solidFill>
               </a:rPr>
-              <a:t>Tai sao can Swagger / OpenAPI?</a:t>
+              <a:t>Tại sao cần Swagger / OpenAPI?</a:t>
             </a:r>
           </a:p>
         </p:txBody>
@@ -9228,7 +9228,7 @@
                   <a:srgbClr val="CCCCCC"/>
                 </a:solidFill>
               </a:rPr>
-              <a:t>  *  API dua ra ngoai ma khong co mo ta -&gt; Ben thu 3 khong biet cach dung.</a:t>
+              <a:t>  •  API đưa ra ngoài mà không có mô tả → Bên thứ 3 không biết cách dùng.</a:t>
             </a:r>
           </a:p>
         </p:txBody>
@@ -9262,7 +9262,7 @@
                   <a:srgbClr val="CCCCCC"/>
                 </a:solidFill>
               </a:rPr>
-              <a:t>  *  OpenAPI la chuan mo ta API duoc ca nganh cong nghiep su dung.</a:t>
+              <a:t>  •  OpenAPI là chuẩn mô tả API được cả ngành công nghiệp sử dụng.</a:t>
             </a:r>
           </a:p>
         </p:txBody>
@@ -9296,7 +9296,7 @@
                   <a:srgbClr val="CCCCCC"/>
                 </a:solidFill>
               </a:rPr>
-              <a:t>  *  Swagger UI tu dong doc code C# -&gt; Sinh trang tai lieu tuong tac day du.</a:t>
+              <a:t>  •  Swagger UI tự động đọc code C# → Sinh trang tài liệu tương tác đầy đủ.</a:t>
             </a:r>
           </a:p>
         </p:txBody>
@@ -9330,7 +9330,7 @@
                   <a:srgbClr val="F5C518"/>
                 </a:solidFill>
               </a:rPr>
-              <a:t>Tinh nang da tich hop</a:t>
+              <a:t>Tính năng đã tích hợp</a:t>
             </a:r>
           </a:p>
         </p:txBody>
@@ -9364,7 +9364,7 @@
                   <a:srgbClr val="CCCCCC"/>
                 </a:solidFill>
               </a:rPr>
-              <a:t>  *  Hien thi day du 2 endpoints, mo ta tham so va response schema.</a:t>
+              <a:t>  •  Hiển thị đầy đủ 2 endpoints, mô tả tham số và response schema.</a:t>
             </a:r>
           </a:p>
         </p:txBody>
@@ -9398,7 +9398,7 @@
                   <a:srgbClr val="CCCCCC"/>
                 </a:solidFill>
               </a:rPr>
-              <a:t>  *  Cho phep Execute request ngay tren giao dien Web — khong can Postman.</a:t>
+              <a:t>  •  Cho phép Execute request ngay trên giao diện Web — không cần Postman.</a:t>
             </a:r>
           </a:p>
         </p:txBody>
@@ -9432,7 +9432,7 @@
                   <a:srgbClr val="CCCCCC"/>
                 </a:solidFill>
               </a:rPr>
-              <a:t>  *  La cong cu Demo truc tiep trong buoi bao cao hom nay.</a:t>
+              <a:t>  •  Là công cụ Demo trực tiếp trong buổi báo cáo hôm nay.</a:t>
             </a:r>
           </a:p>
         </p:txBody>
@@ -9509,7 +9509,7 @@
                   <a:srgbClr val="86EFAC"/>
                 </a:solidFill>
               </a:rPr>
-              <a:t>Swagger chinh la cong giao tiep giua nhom va the gioi ben ngoai.</a:t>
+              <a:t>Swagger chính là cổng giao tiếp giữa nhóm và thế giới bên ngoài.</a:t>
             </a:r>
           </a:p>
         </p:txBody>
@@ -9655,7 +9655,7 @@
                   <a:srgbClr val="F5C518"/>
                 </a:solidFill>
               </a:rPr>
-              <a:t>  Quoc Dat</a:t>
+              <a:t>  Quốc Đạt</a:t>
             </a:r>
           </a:p>
         </p:txBody>
@@ -9689,7 +9689,7 @@
                   <a:srgbClr val="FFFFFF"/>
                 </a:solidFill>
               </a:rPr>
-              <a:t>Slide 4 - Tich Hop API Ben Thu 3 (Binance &amp; ExchangeRate)</a:t>
+              <a:t>Slide 4 · Tích Hợp API Bên Thứ 3 (Binance &amp; ExchangeRate)</a:t>
             </a:r>
           </a:p>
         </p:txBody>
@@ -9766,7 +9766,7 @@
                   <a:srgbClr val="F5C518"/>
                 </a:solidFill>
               </a:rPr>
-              <a:t>Bai thi 3: Su dung API tu nguon ben ngoai (3rd-Party APIs)</a:t>
+              <a:t>Bài thi 3: Sử dụng API từ nguồn bên ngoài (3rd-Party APIs)</a:t>
             </a:r>
           </a:p>
         </p:txBody>
@@ -9800,7 +9800,7 @@
                   <a:srgbClr val="CCCCCC"/>
                 </a:solidFill>
               </a:rPr>
-              <a:t>Server khong cho User nhap lieu — tu dong goi ra 2 nguon du lieu thuc te:</a:t>
+              <a:t>Server không chờ User nhập liệu — tự động gọi ra 2 nguồn dữ liệu thực tế:</a:t>
             </a:r>
           </a:p>
         </p:txBody>
@@ -9954,7 +9954,7 @@
                   <a:srgbClr val="CCCCCC"/>
                 </a:solidFill>
               </a:rPr>
-              <a:t>Muc dich: Lay gia Vang Spot theo phien giao dich</a:t>
+              <a:t>Mục đích: Lấy giá Vàng Spot theo phiên giao dịch</a:t>
             </a:r>
           </a:p>
         </p:txBody>
@@ -10100,7 +10100,7 @@
                   <a:srgbClr val="86EFAC"/>
                 </a:solidFill>
               </a:rPr>
-              <a:t>Trich xuat: Open, High, Low, Volume (tu mang Klines JSON)</a:t>
+              <a:t>Trích xuất: Open, High, Low, Volume (từ mảng Klines JSON)</a:t>
             </a:r>
           </a:p>
         </p:txBody>
@@ -10254,7 +10254,7 @@
                   <a:srgbClr val="CCCCCC"/>
                 </a:solidFill>
               </a:rPr>
-              <a:t>Muc dich: Lay ty gia USD -&gt; VND hien tai</a:t>
+              <a:t>Mục đích: Lấy tỷ giá USD → VND hiện tại</a:t>
             </a:r>
           </a:p>
         </p:txBody>
@@ -10399,7 +10399,7 @@
                   <a:srgbClr val="86EFAC"/>
                 </a:solidFill>
               </a:rPr>
-              <a:t>Trich xuat: rates.VND (tu object JSON phan hoi)</a:t>
+              <a:t>Trích xuất: rates.VND (từ object JSON phản hồi)</a:t>
             </a:r>
           </a:p>
         </p:txBody>
@@ -10476,7 +10476,7 @@
                   <a:srgbClr val="86EFAC"/>
                 </a:solidFill>
               </a:rPr>
-              <a:t>Ket qua: PredictedClose (USD)  x  ty gia VND  =  Gia Vang VND hien tai</a:t>
+              <a:t>Kết quả: PredictedClose (USD)  x  tỷ giá VND  =  Giá Vàng VND hiện tại</a:t>
             </a:r>
           </a:p>
         </p:txBody>
@@ -10622,7 +10622,7 @@
                   <a:srgbClr val="F5C518"/>
                 </a:solidFill>
               </a:rPr>
-              <a:t>  Quoc Dat</a:t>
+              <a:t>  Quốc Đạt</a:t>
             </a:r>
           </a:p>
         </p:txBody>
@@ -10656,7 +10656,7 @@
                   <a:srgbClr val="FFFFFF"/>
                 </a:solidFill>
               </a:rPr>
-              <a:t>Slide 5 - Xu Ly Bat Dong Bo &amp; Phan Tich JSON</a:t>
+              <a:t>Slide 5 · Xử Lý Bất Đồng Bộ &amp; Phân Tích JSON</a:t>
             </a:r>
           </a:p>
         </p:txBody>
@@ -10733,7 +10733,7 @@
                   <a:srgbClr val="F5C518"/>
                 </a:solidFill>
               </a:rPr>
-              <a:t>Luong xu ly ben trong /realtime endpoint (bat dong bo):</a:t>
+              <a:t>Luồng xử lý bên trong /realtime endpoint (bất đồng bộ):</a:t>
             </a:r>
           </a:p>
         </p:txBody>
@@ -10814,9 +10814,9 @@
    -&gt; Nhan JSON Klines -&gt; Trich Open, High, Low, Volume
 2. Server gui HTTP GET -&gt; Exchange Rates API
    -&gt; Doc node 'VND' -&gt; Nhan ty gia
-3. Gop 4 gia tri -&gt; Dua vao AI Model
+3. Gop 4 gia tri -&gt; Model AI tinh toan
    -&gt; AI tra ve PredictedClose (USD)
-4. Tinh: PredictedClose x VND_Rate = Gia VND
+4. PredictedClose x VND_Rate = Gia VND
    -&gt; Tra ve JSON cho Client</a:t>
             </a:r>
           </a:p>
@@ -10851,7 +10851,7 @@
                   <a:srgbClr val="F5C518"/>
                 </a:solidFill>
               </a:rPr>
-              <a:t>Tai sao dung async/await?</a:t>
+              <a:t>Tại sao dùng async/await?</a:t>
             </a:r>
           </a:p>
         </p:txBody>
@@ -10885,7 +10885,7 @@
                   <a:srgbClr val="CCCCCC"/>
                 </a:solidFill>
               </a:rPr>
-              <a:t>  *  Server khong bi 'dung' khi cho mang.</a:t>
+              <a:t>  •  Server không bị 'đứng' khi chờ mạng.</a:t>
             </a:r>
           </a:p>
         </p:txBody>
@@ -10919,7 +10919,7 @@
                   <a:srgbClr val="CCCCCC"/>
                 </a:solidFill>
               </a:rPr>
-              <a:t>  *  Xu ly nhieu request dong thoi.</a:t>
+              <a:t>  •  Xử lý nhiều request đồng thời.</a:t>
             </a:r>
           </a:p>
         </p:txBody>
@@ -10953,7 +10953,7 @@
                   <a:srgbClr val="CCCCCC"/>
                 </a:solidFill>
               </a:rPr>
-              <a:t>  *  Tang throughput tong the.</a:t>
+              <a:t>  •  Tăng throughput tổng thể.</a:t>
             </a:r>
           </a:p>
         </p:txBody>
@@ -10987,7 +10987,7 @@
                   <a:srgbClr val="CCCCCC"/>
                 </a:solidFill>
               </a:rPr>
-              <a:t>  *  </a:t>
+              <a:t>  •  </a:t>
             </a:r>
           </a:p>
         </p:txBody>
@@ -11021,7 +11021,7 @@
                   <a:srgbClr val="CCCCCC"/>
                 </a:solidFill>
               </a:rPr>
-              <a:t>  *  Ky thuat: Task&lt;IResult&gt;</a:t>
+              <a:t>  •  Kỹ thuật: Task&lt;IResult&gt;</a:t>
             </a:r>
           </a:p>
         </p:txBody>
@@ -11055,7 +11055,7 @@
                   <a:srgbClr val="CCCCCC"/>
                 </a:solidFill>
               </a:rPr>
-              <a:t>  *  JSON: System.Text.Json DOM tree</a:t>
+              <a:t>  •  JSON: System.Text.Json DOM tree</a:t>
             </a:r>
           </a:p>
         </p:txBody>
@@ -11089,7 +11089,7 @@
                   <a:srgbClr val="CCCCCC"/>
                 </a:solidFill>
               </a:rPr>
-              <a:t>  *  -&gt; Chi doc dung node can thiet,</a:t>
+              <a:t>  •  → Chỉ đọc đúng node cần thiết,</a:t>
             </a:r>
           </a:p>
         </p:txBody>
@@ -11123,7 +11123,7 @@
                   <a:srgbClr val="CCCCCC"/>
                 </a:solidFill>
               </a:rPr>
-              <a:t>  *  khong map toan bo object.</a:t>
+              <a:t>  •  không map toàn bộ object.</a:t>
             </a:r>
           </a:p>
         </p:txBody>
@@ -11269,7 +11269,7 @@
                   <a:srgbClr val="F5C518"/>
                 </a:solidFill>
               </a:rPr>
-              <a:t>  Quoc Dat</a:t>
+              <a:t>  Quốc Đạt</a:t>
             </a:r>
           </a:p>
         </p:txBody>
@@ -11303,7 +11303,7 @@
                   <a:srgbClr val="FFFFFF"/>
                 </a:solidFill>
               </a:rPr>
-              <a:t>Slide 6 - IHttpClientFactory - Goi API Chuyen Nghiep</a:t>
+              <a:t>Slide 6 · IHttpClientFactory - Gọi API Chuyên Nghiệp</a:t>
             </a:r>
           </a:p>
         </p:txBody>
@@ -11380,7 +11380,7 @@
                   <a:srgbClr val="F5C518"/>
                 </a:solidFill>
               </a:rPr>
-              <a:t>Van de khi dung new HttpClient() truc tiep:</a:t>
+              <a:t>Vấn đề khi dùng new HttpClient() trực tiếp:</a:t>
             </a:r>
           </a:p>
         </p:txBody>
@@ -11414,7 +11414,7 @@
                   <a:srgbClr val="CCCCCC"/>
                 </a:solidFill>
               </a:rPr>
-              <a:t>  *  Moi Request tao ra mot ket noi Socket moi -&gt; Can kiet Port (Socket Exhaustion).</a:t>
+              <a:t>  •  Mỗi Request tạo ra một kết nối Socket mới → Cạn kiệt Port (Socket Exhaustion).</a:t>
             </a:r>
           </a:p>
         </p:txBody>
@@ -11448,7 +11448,7 @@
                   <a:srgbClr val="CCCCCC"/>
                 </a:solidFill>
               </a:rPr>
-              <a:t>  *  Anh huong nghiem trong khi co hang tram nguoi dung goi API dong thoi.</a:t>
+              <a:t>  •  Ảnh hưởng nghiêm trọng khi có hàng trăm người dùng gọi API đồng thời.</a:t>
             </a:r>
           </a:p>
         </p:txBody>
@@ -11482,7 +11482,7 @@
                   <a:srgbClr val="F5C518"/>
                 </a:solidFill>
               </a:rPr>
-              <a:t>Giai phap: IHttpClientFactory</a:t>
+              <a:t>Giải pháp: IHttpClientFactory</a:t>
             </a:r>
           </a:p>
         </p:txBody>
@@ -11516,7 +11516,7 @@
                   <a:srgbClr val="CCCCCC"/>
                 </a:solidFill>
               </a:rPr>
-              <a:t>  *  Dang ky vao Dependency Injection Container — quan ly vong doi bo goi HTTP.</a:t>
+              <a:t>  •  Đăng ký vào Dependency Injection Container — quản lý vòng đời bộ gọi HTTP.</a:t>
             </a:r>
           </a:p>
         </p:txBody>
@@ -11550,7 +11550,7 @@
                   <a:srgbClr val="CCCCCC"/>
                 </a:solidFill>
               </a:rPr>
-              <a:t>  *  Tai su dung ket noi Socket hieu qua -&gt; Khong bao gio bi can kiet Port.</a:t>
+              <a:t>  •  Tái sử dụng kết nối Socket hiệu quả → Không bao giờ bị cạn kiệt Port.</a:t>
             </a:r>
           </a:p>
         </p:txBody>
@@ -11584,7 +11584,7 @@
                   <a:srgbClr val="CCCCCC"/>
                 </a:solidFill>
               </a:rPr>
-              <a:t>Cau hinh — chi 1 dong trong ServiceExtensions.cs:</a:t>
+              <a:t>Cấu hình — chỉ 1 dòng trong ServiceExtensions.cs:</a:t>
             </a:r>
           </a:p>
         </p:txBody>
@@ -11738,7 +11738,7 @@
                   <a:srgbClr val="3B82F6"/>
                 </a:solidFill>
               </a:rPr>
-              <a:t>Thay doi nho trong DI Container, ngan chan toan bo nguy co Port Exhaustion khi scale.</a:t>
+              <a:t>Thay đổi nhỏ trong DI Container, ngăn chặn toàn bộ nguy cơ Port Exhaustion khi scale.</a:t>
             </a:r>
           </a:p>
         </p:txBody>
@@ -11884,7 +11884,7 @@
                   <a:srgbClr val="F5C518"/>
                 </a:solidFill>
               </a:rPr>
-              <a:t>  Van Nguyen</a:t>
+              <a:t>  Văn Nguyễn</a:t>
             </a:r>
           </a:p>
         </p:txBody>
@@ -11918,7 +11918,7 @@
                   <a:srgbClr val="FFFFFF"/>
                 </a:solidFill>
               </a:rPr>
-              <a:t>Slide 7 - Bai Toan Hieu Nang - Hosting ML Model</a:t>
+              <a:t>Slide 7 · Bài Toán Hiệu Năng - Hosting ML Model</a:t>
             </a:r>
           </a:p>
         </p:txBody>
@@ -11995,7 +11995,7 @@
                   <a:srgbClr val="F5C518"/>
                 </a:solidFill>
               </a:rPr>
-              <a:t>Van de dac thu khi Host Machine Learning lam REST API:</a:t>
+              <a:t>Vấn đề đặc thù khi Host Machine Learning làm REST API:</a:t>
             </a:r>
           </a:p>
         </p:txBody>
@@ -12029,7 +12029,7 @@
                   <a:srgbClr val="CCCCCC"/>
                 </a:solidFill>
               </a:rPr>
-              <a:t>  *  File GoldModel.zip nang ~43MB — chua toan bo cau truc than kinh nhan tao.</a:t>
+              <a:t>  •  File GoldModel.zip nặng ~43MB — chứa toàn bộ cấu trúc thần kinh nhân tạo.</a:t>
             </a:r>
           </a:p>
         </p:txBody>
@@ -12063,7 +12063,7 @@
                   <a:srgbClr val="CCCCCC"/>
                 </a:solidFill>
               </a:rPr>
-              <a:t>  *  Neu nap lai model moi lan co Request -&gt; Ton hang giay xu ly moi luot goi.</a:t>
+              <a:t>  •  Nếu nạp lại model mỗi lần có Request → Tốn hàng giây xử lý mỗi lượt gọi.</a:t>
             </a:r>
           </a:p>
         </p:txBody>
@@ -12097,7 +12097,7 @@
                   <a:srgbClr val="CCCCCC"/>
                 </a:solidFill>
               </a:rPr>
-              <a:t>  *  Hang tram nguoi dung dong thoi -&gt; Memory Leak -&gt; Server Crash.</a:t>
+              <a:t>  •  Hàng trăm người dùng đồng thời → Memory Leak → Server Crash.</a:t>
             </a:r>
           </a:p>
         </p:txBody>
@@ -12131,7 +12131,7 @@
                   <a:srgbClr val="F87171"/>
                 </a:solidFill>
               </a:rPr>
-              <a:t>Kich ban nguy hiem:</a:t>
+              <a:t>Kịch bản nguy hiểm:</a:t>
             </a:r>
           </a:p>
         </p:txBody>
@@ -12208,7 +12208,7 @@
                   <a:srgbClr val="F5C518"/>
                 </a:solidFill>
               </a:rPr>
-              <a:t>// WRONG — nap lai model moi request
+              <a:t>// SAI -- nap lai model moi request
 app.MapPost('/predict', (input) =&gt; {
     var ctx = new MLContext();
     var model = ctx.Model.Load('GoldModel.zip', ...);
@@ -12359,7 +12359,7 @@
                   <a:srgbClr val="F5C518"/>
                 </a:solidFill>
               </a:rPr>
-              <a:t>  Van Nguyen</a:t>
+              <a:t>  Văn Nguyễn</a:t>
             </a:r>
           </a:p>
         </p:txBody>
@@ -12393,7 +12393,7 @@
                   <a:srgbClr val="FFFFFF"/>
                 </a:solidFill>
               </a:rPr>
-              <a:t>Slide 8 - PredictionEnginePool - Quan Tri RAM</a:t>
+              <a:t>Slide 8 · PredictionEnginePool - Quản Trị RAM</a:t>
             </a:r>
           </a:p>
         </p:txBody>
@@ -12470,7 +12470,7 @@
                   <a:srgbClr val="F5C518"/>
                 </a:solidFill>
               </a:rPr>
-              <a:t>Giai phap: PredictionEnginePool (Object Pooling)</a:t>
+              <a:t>Giải pháp: PredictionEnginePool (Object Pooling)</a:t>
             </a:r>
           </a:p>
         </p:txBody>
@@ -12547,7 +12547,7 @@
                   <a:srgbClr val="F5C518"/>
                 </a:solidFill>
               </a:rPr>
-              <a:t>// CORRECT — dang ky 1 lan duy nhat luc Server khoi dong
+              <a:t>// DUNG -- dang ky 1 lan duy nhat luc Server khoi dong
 builder.Services.AddPredictionEnginePool&lt;ModelInput, ModelOutput&gt;(
     modelName: 'GoldModel',
     modelBuilder: ctx =&gt; ctx.Model.Load('GoldModel.zip', ...)
@@ -12585,7 +12585,7 @@
                   <a:srgbClr val="F5C518"/>
                 </a:solidFill>
               </a:rPr>
-              <a:t>Co che hoat dong:</a:t>
+              <a:t>Cơ chế hoạt động:</a:t>
             </a:r>
           </a:p>
         </p:txBody>
@@ -12619,7 +12619,7 @@
                   <a:srgbClr val="CCCCCC"/>
                 </a:solidFill>
               </a:rPr>
-              <a:t>  *  Server start -&gt; Nap model vao RAM dung 1 lan.</a:t>
+              <a:t>  •  Server start → Nạp model vào RAM đúng 1 lần.</a:t>
             </a:r>
           </a:p>
         </p:txBody>
@@ -12653,7 +12653,7 @@
                   <a:srgbClr val="CCCCCC"/>
                 </a:solidFill>
               </a:rPr>
-              <a:t>  *  Request den -&gt; Muon Engine -&gt; Du bao -&gt; Tra lai Pool.</a:t>
+              <a:t>  •  Request đến → Mượn Engine → Dự báo → Trả lại Pool.</a:t>
             </a:r>
           </a:p>
         </p:txBody>
@@ -12687,7 +12687,7 @@
                   <a:srgbClr val="CCCCCC"/>
                 </a:solidFill>
               </a:rPr>
-              <a:t>  *  Thread-Safe: Ngan requests song song, khong xung dot.</a:t>
+              <a:t>  •  Thread-Safe: Ngàn requests song song, không xung đột.</a:t>
             </a:r>
           </a:p>
         </p:txBody>
@@ -12721,7 +12721,7 @@
                   <a:srgbClr val="CCCCCC"/>
                 </a:solidFill>
               </a:rPr>
-              <a:t>  *  Zero Memory Leak: Pool tu quan ly vong doi object.</a:t>
+              <a:t>  •  Zero Memory Leak: Pool tự quản lý vòng đời object.</a:t>
             </a:r>
           </a:p>
         </p:txBody>

</xml_diff>

<commit_message>
docs: add modern HTML presentation and clean up old files
</commit_message>
<xml_diff>
--- a/X-AURUM_Presentation.pptx
+++ b/X-AURUM_Presentation.pptx
@@ -5,22 +5,22 @@
     <p:sldMasterId id="2147483648" r:id="rId1"/>
   </p:sldMasterIdLst>
   <p:sldIdLst>
-    <p:sldId id="256" r:id="rId7"/>
-    <p:sldId id="257" r:id="rId8"/>
-    <p:sldId id="258" r:id="rId9"/>
-    <p:sldId id="259" r:id="rId10"/>
-    <p:sldId id="260" r:id="rId11"/>
-    <p:sldId id="261" r:id="rId12"/>
-    <p:sldId id="262" r:id="rId13"/>
-    <p:sldId id="263" r:id="rId14"/>
-    <p:sldId id="264" r:id="rId15"/>
-    <p:sldId id="265" r:id="rId16"/>
-    <p:sldId id="266" r:id="rId17"/>
-    <p:sldId id="267" r:id="rId18"/>
-    <p:sldId id="268" r:id="rId19"/>
-    <p:sldId id="269" r:id="rId20"/>
+    <p:sldId id="256" r:id="rId2"/>
+    <p:sldId id="257" r:id="rId3"/>
+    <p:sldId id="258" r:id="rId4"/>
+    <p:sldId id="259" r:id="rId5"/>
+    <p:sldId id="260" r:id="rId6"/>
+    <p:sldId id="261" r:id="rId7"/>
+    <p:sldId id="262" r:id="rId8"/>
+    <p:sldId id="263" r:id="rId9"/>
+    <p:sldId id="264" r:id="rId10"/>
+    <p:sldId id="265" r:id="rId11"/>
+    <p:sldId id="266" r:id="rId12"/>
+    <p:sldId id="267" r:id="rId13"/>
+    <p:sldId id="268" r:id="rId14"/>
+    <p:sldId id="269" r:id="rId15"/>
   </p:sldIdLst>
-  <p:sldSz cx="12188952" cy="6858000" type="screen4x3"/>
+  <p:sldSz cx="12188825" cy="6858000"/>
   <p:notesSz cx="6858000" cy="9144000"/>
   <p:defaultTextStyle>
     <a:defPPr>
@@ -117,6 +117,22 @@
       </a:defRPr>
     </a:lvl9pPr>
   </p:defaultTextStyle>
+  <p:extLst>
+    <p:ext uri="{EFAFB233-063F-42B5-8137-9DF3F51BA10A}">
+      <p15:sldGuideLst xmlns:p15="http://schemas.microsoft.com/office/powerpoint/2012/main">
+        <p15:guide id="1" orient="horz" pos="2160">
+          <p15:clr>
+            <a:srgbClr val="A4A3A4"/>
+          </p15:clr>
+        </p15:guide>
+        <p15:guide id="2" pos="2880">
+          <p15:clr>
+            <a:srgbClr val="A4A3A4"/>
+          </p15:clr>
+        </p15:guide>
+      </p15:sldGuideLst>
+    </p:ext>
+  </p:extLst>
 </p:presentation>
 </file>
 
@@ -301,7 +317,7 @@
           <a:p>
             <a:fld id="{5BCAD085-E8A6-8845-BD4E-CB4CCA059FC4}" type="datetimeFigureOut">
               <a:rPr lang="en-US" smtClean="0"/>
-              <a:t>1/27/13</a:t>
+              <a:t>7/5/2026</a:t>
             </a:fld>
             <a:endParaRPr lang="en-US"/>
           </a:p>
@@ -471,7 +487,7 @@
           <a:p>
             <a:fld id="{5BCAD085-E8A6-8845-BD4E-CB4CCA059FC4}" type="datetimeFigureOut">
               <a:rPr lang="en-US" smtClean="0"/>
-              <a:t>1/27/13</a:t>
+              <a:t>7/5/2026</a:t>
             </a:fld>
             <a:endParaRPr lang="en-US"/>
           </a:p>
@@ -651,7 +667,7 @@
           <a:p>
             <a:fld id="{5BCAD085-E8A6-8845-BD4E-CB4CCA059FC4}" type="datetimeFigureOut">
               <a:rPr lang="en-US" smtClean="0"/>
-              <a:t>1/27/13</a:t>
+              <a:t>7/5/2026</a:t>
             </a:fld>
             <a:endParaRPr lang="en-US"/>
           </a:p>
@@ -821,7 +837,7 @@
           <a:p>
             <a:fld id="{5BCAD085-E8A6-8845-BD4E-CB4CCA059FC4}" type="datetimeFigureOut">
               <a:rPr lang="en-US" smtClean="0"/>
-              <a:t>1/27/13</a:t>
+              <a:t>7/5/2026</a:t>
             </a:fld>
             <a:endParaRPr lang="en-US"/>
           </a:p>
@@ -1067,7 +1083,7 @@
           <a:p>
             <a:fld id="{5BCAD085-E8A6-8845-BD4E-CB4CCA059FC4}" type="datetimeFigureOut">
               <a:rPr lang="en-US" smtClean="0"/>
-              <a:t>1/27/13</a:t>
+              <a:t>7/5/2026</a:t>
             </a:fld>
             <a:endParaRPr lang="en-US"/>
           </a:p>
@@ -1355,7 +1371,7 @@
           <a:p>
             <a:fld id="{5BCAD085-E8A6-8845-BD4E-CB4CCA059FC4}" type="datetimeFigureOut">
               <a:rPr lang="en-US" smtClean="0"/>
-              <a:t>1/27/13</a:t>
+              <a:t>7/5/2026</a:t>
             </a:fld>
             <a:endParaRPr lang="en-US"/>
           </a:p>
@@ -1777,7 +1793,7 @@
           <a:p>
             <a:fld id="{5BCAD085-E8A6-8845-BD4E-CB4CCA059FC4}" type="datetimeFigureOut">
               <a:rPr lang="en-US" smtClean="0"/>
-              <a:t>1/27/13</a:t>
+              <a:t>7/5/2026</a:t>
             </a:fld>
             <a:endParaRPr lang="en-US"/>
           </a:p>
@@ -1895,7 +1911,7 @@
           <a:p>
             <a:fld id="{5BCAD085-E8A6-8845-BD4E-CB4CCA059FC4}" type="datetimeFigureOut">
               <a:rPr lang="en-US" smtClean="0"/>
-              <a:t>1/27/13</a:t>
+              <a:t>7/5/2026</a:t>
             </a:fld>
             <a:endParaRPr lang="en-US"/>
           </a:p>
@@ -1990,7 +2006,7 @@
           <a:p>
             <a:fld id="{5BCAD085-E8A6-8845-BD4E-CB4CCA059FC4}" type="datetimeFigureOut">
               <a:rPr lang="en-US" smtClean="0"/>
-              <a:t>1/27/13</a:t>
+              <a:t>7/5/2026</a:t>
             </a:fld>
             <a:endParaRPr lang="en-US"/>
           </a:p>
@@ -2267,7 +2283,7 @@
           <a:p>
             <a:fld id="{5BCAD085-E8A6-8845-BD4E-CB4CCA059FC4}" type="datetimeFigureOut">
               <a:rPr lang="en-US" smtClean="0"/>
-              <a:t>1/27/13</a:t>
+              <a:t>7/5/2026</a:t>
             </a:fld>
             <a:endParaRPr lang="en-US"/>
           </a:p>
@@ -2520,7 +2536,7 @@
           <a:p>
             <a:fld id="{5BCAD085-E8A6-8845-BD4E-CB4CCA059FC4}" type="datetimeFigureOut">
               <a:rPr lang="en-US" smtClean="0"/>
-              <a:t>1/27/13</a:t>
+              <a:t>7/5/2026</a:t>
             </a:fld>
             <a:endParaRPr lang="en-US"/>
           </a:p>
@@ -2733,7 +2749,7 @@
           <a:p>
             <a:fld id="{5BCAD085-E8A6-8845-BD4E-CB4CCA059FC4}" type="datetimeFigureOut">
               <a:rPr lang="en-US" smtClean="0"/>
-              <a:t>1/27/13</a:t>
+              <a:t>7/5/2026</a:t>
             </a:fld>
             <a:endParaRPr lang="en-US"/>
           </a:p>
@@ -3092,7 +3108,7 @@
 </file>
 
 <file path=ppt/slides/slide1.xml><?xml version="1.0" encoding="utf-8"?>
-<p:sld xmlns:a="http://schemas.openxmlformats.org/drawingml/2006/main" xmlns:p="http://schemas.openxmlformats.org/presentationml/2006/main" xmlns:r="http://schemas.openxmlformats.org/officeDocument/2006/relationships">
+<p:sld xmlns:a="http://schemas.openxmlformats.org/drawingml/2006/main" xmlns:r="http://schemas.openxmlformats.org/officeDocument/2006/relationships" xmlns:p="http://schemas.openxmlformats.org/presentationml/2006/main">
   <p:cSld>
     <p:bg>
       <p:bgPr>
@@ -3108,7 +3124,14 @@
         <p:cNvGrpSpPr/>
         <p:nvPr/>
       </p:nvGrpSpPr>
-      <p:grpSpPr/>
+      <p:grpSpPr>
+        <a:xfrm>
+          <a:off x="0" y="0"/>
+          <a:ext cx="0" cy="0"/>
+          <a:chOff x="0" y="0"/>
+          <a:chExt cx="0" cy="0"/>
+        </a:xfrm>
+      </p:grpSpPr>
       <p:sp>
         <p:nvSpPr>
           <p:cNvPr id="2" name="Rectangle 1"/>
@@ -3149,6 +3172,7 @@
           <a:lstStyle/>
           <a:p>
             <a:pPr algn="ctr"/>
+            <a:endParaRPr/>
           </a:p>
         </p:txBody>
       </p:sp>
@@ -3192,6 +3216,7 @@
           <a:lstStyle/>
           <a:p>
             <a:pPr algn="ctr"/>
+            <a:endParaRPr/>
           </a:p>
         </p:txBody>
       </p:sp>
@@ -3337,6 +3362,7 @@
           <a:lstStyle/>
           <a:p>
             <a:pPr algn="ctr"/>
+            <a:endParaRPr/>
           </a:p>
         </p:txBody>
       </p:sp>
@@ -3417,7 +3443,7 @@
 </file>
 
 <file path=ppt/slides/slide10.xml><?xml version="1.0" encoding="utf-8"?>
-<p:sld xmlns:a="http://schemas.openxmlformats.org/drawingml/2006/main" xmlns:p="http://schemas.openxmlformats.org/presentationml/2006/main" xmlns:r="http://schemas.openxmlformats.org/officeDocument/2006/relationships">
+<p:sld xmlns:a="http://schemas.openxmlformats.org/drawingml/2006/main" xmlns:r="http://schemas.openxmlformats.org/officeDocument/2006/relationships" xmlns:p="http://schemas.openxmlformats.org/presentationml/2006/main">
   <p:cSld>
     <p:bg>
       <p:bgPr>
@@ -3433,7 +3459,14 @@
         <p:cNvGrpSpPr/>
         <p:nvPr/>
       </p:nvGrpSpPr>
-      <p:grpSpPr/>
+      <p:grpSpPr>
+        <a:xfrm>
+          <a:off x="0" y="0"/>
+          <a:ext cx="0" cy="0"/>
+          <a:chOff x="0" y="0"/>
+          <a:chExt cx="0" cy="0"/>
+        </a:xfrm>
+      </p:grpSpPr>
       <p:sp>
         <p:nvSpPr>
           <p:cNvPr id="2" name="Rectangle 1"/>
@@ -3474,6 +3507,7 @@
           <a:lstStyle/>
           <a:p>
             <a:pPr algn="ctr"/>
+            <a:endParaRPr/>
           </a:p>
         </p:txBody>
       </p:sp>
@@ -3517,6 +3551,7 @@
           <a:lstStyle/>
           <a:p>
             <a:pPr algn="ctr"/>
+            <a:endParaRPr/>
           </a:p>
         </p:txBody>
       </p:sp>
@@ -3628,6 +3663,7 @@
           <a:lstStyle/>
           <a:p>
             <a:pPr algn="ctr"/>
+            <a:endParaRPr/>
           </a:p>
         </p:txBody>
       </p:sp>
@@ -3739,6 +3775,7 @@
           <a:lstStyle/>
           <a:p>
             <a:pPr algn="ctr"/>
+            <a:endParaRPr/>
           </a:p>
         </p:txBody>
       </p:sp>
@@ -3852,6 +3889,7 @@
           <a:lstStyle/>
           <a:p>
             <a:pPr algn="ctr"/>
+            <a:endParaRPr/>
           </a:p>
         </p:txBody>
       </p:sp>
@@ -3966,6 +4004,7 @@
           <a:lstStyle/>
           <a:p>
             <a:pPr algn="ctr"/>
+            <a:endParaRPr/>
           </a:p>
         </p:txBody>
       </p:sp>
@@ -4012,7 +4051,7 @@
 </file>
 
 <file path=ppt/slides/slide11.xml><?xml version="1.0" encoding="utf-8"?>
-<p:sld xmlns:a="http://schemas.openxmlformats.org/drawingml/2006/main" xmlns:p="http://schemas.openxmlformats.org/presentationml/2006/main" xmlns:r="http://schemas.openxmlformats.org/officeDocument/2006/relationships">
+<p:sld xmlns:a="http://schemas.openxmlformats.org/drawingml/2006/main" xmlns:r="http://schemas.openxmlformats.org/officeDocument/2006/relationships" xmlns:p="http://schemas.openxmlformats.org/presentationml/2006/main">
   <p:cSld>
     <p:bg>
       <p:bgPr>
@@ -4028,7 +4067,14 @@
         <p:cNvGrpSpPr/>
         <p:nvPr/>
       </p:nvGrpSpPr>
-      <p:grpSpPr/>
+      <p:grpSpPr>
+        <a:xfrm>
+          <a:off x="0" y="0"/>
+          <a:ext cx="0" cy="0"/>
+          <a:chOff x="0" y="0"/>
+          <a:chExt cx="0" cy="0"/>
+        </a:xfrm>
+      </p:grpSpPr>
       <p:sp>
         <p:nvSpPr>
           <p:cNvPr id="2" name="Rectangle 1"/>
@@ -4069,6 +4115,7 @@
           <a:lstStyle/>
           <a:p>
             <a:pPr algn="ctr"/>
+            <a:endParaRPr/>
           </a:p>
         </p:txBody>
       </p:sp>
@@ -4112,6 +4159,7 @@
           <a:lstStyle/>
           <a:p>
             <a:pPr algn="ctr"/>
+            <a:endParaRPr/>
           </a:p>
         </p:txBody>
       </p:sp>
@@ -4223,6 +4271,7 @@
           <a:lstStyle/>
           <a:p>
             <a:pPr algn="ctr"/>
+            <a:endParaRPr/>
           </a:p>
         </p:txBody>
       </p:sp>
@@ -4334,6 +4383,7 @@
           <a:lstStyle/>
           <a:p>
             <a:pPr algn="ctr"/>
+            <a:endParaRPr/>
           </a:p>
         </p:txBody>
       </p:sp>
@@ -4658,7 +4708,7 @@
 </file>
 
 <file path=ppt/slides/slide12.xml><?xml version="1.0" encoding="utf-8"?>
-<p:sld xmlns:a="http://schemas.openxmlformats.org/drawingml/2006/main" xmlns:p="http://schemas.openxmlformats.org/presentationml/2006/main" xmlns:r="http://schemas.openxmlformats.org/officeDocument/2006/relationships">
+<p:sld xmlns:a="http://schemas.openxmlformats.org/drawingml/2006/main" xmlns:r="http://schemas.openxmlformats.org/officeDocument/2006/relationships" xmlns:p="http://schemas.openxmlformats.org/presentationml/2006/main">
   <p:cSld>
     <p:bg>
       <p:bgPr>
@@ -4674,7 +4724,14 @@
         <p:cNvGrpSpPr/>
         <p:nvPr/>
       </p:nvGrpSpPr>
-      <p:grpSpPr/>
+      <p:grpSpPr>
+        <a:xfrm>
+          <a:off x="0" y="0"/>
+          <a:ext cx="0" cy="0"/>
+          <a:chOff x="0" y="0"/>
+          <a:chExt cx="0" cy="0"/>
+        </a:xfrm>
+      </p:grpSpPr>
       <p:sp>
         <p:nvSpPr>
           <p:cNvPr id="2" name="Rectangle 1"/>
@@ -4715,6 +4772,7 @@
           <a:lstStyle/>
           <a:p>
             <a:pPr algn="ctr"/>
+            <a:endParaRPr/>
           </a:p>
         </p:txBody>
       </p:sp>
@@ -4758,6 +4816,7 @@
           <a:lstStyle/>
           <a:p>
             <a:pPr algn="ctr"/>
+            <a:endParaRPr/>
           </a:p>
         </p:txBody>
       </p:sp>
@@ -4869,6 +4928,7 @@
           <a:lstStyle/>
           <a:p>
             <a:pPr algn="ctr"/>
+            <a:endParaRPr/>
           </a:p>
         </p:txBody>
       </p:sp>
@@ -4946,6 +5006,7 @@
           <a:lstStyle/>
           <a:p>
             <a:pPr algn="ctr"/>
+            <a:endParaRPr/>
           </a:p>
         </p:txBody>
       </p:sp>
@@ -5023,6 +5084,7 @@
           <a:lstStyle/>
           <a:p>
             <a:pPr algn="ctr"/>
+            <a:endParaRPr/>
           </a:p>
         </p:txBody>
       </p:sp>
@@ -5100,6 +5162,7 @@
           <a:lstStyle/>
           <a:p>
             <a:pPr algn="ctr"/>
+            <a:endParaRPr/>
           </a:p>
         </p:txBody>
       </p:sp>
@@ -5177,6 +5240,7 @@
           <a:lstStyle/>
           <a:p>
             <a:pPr algn="ctr"/>
+            <a:endParaRPr/>
           </a:p>
         </p:txBody>
       </p:sp>
@@ -5254,6 +5318,7 @@
           <a:lstStyle/>
           <a:p>
             <a:pPr algn="ctr"/>
+            <a:endParaRPr/>
           </a:p>
         </p:txBody>
       </p:sp>
@@ -5395,40 +5460,6 @@
       </p:sp>
       <p:sp>
         <p:nvSpPr>
-          <p:cNvPr id="21" name="TextBox 20"/>
-          <p:cNvSpPr txBox="1"/>
-          <p:nvPr/>
-        </p:nvSpPr>
-        <p:spPr>
-          <a:xfrm>
-            <a:off x="6583680" y="2606039"/>
-            <a:ext cx="5212080" cy="365760"/>
-          </a:xfrm>
-          <a:prstGeom prst="rect">
-            <a:avLst/>
-          </a:prstGeom>
-          <a:noFill/>
-        </p:spPr>
-        <p:txBody>
-          <a:bodyPr wrap="square">
-            <a:spAutoFit/>
-          </a:bodyPr>
-          <a:lstStyle/>
-          <a:p>
-            <a:pPr algn="l"/>
-            <a:r>
-              <a:rPr sz="1300" b="0" i="0">
-                <a:solidFill>
-                  <a:srgbClr val="CCCCCC"/>
-                </a:solidFill>
-              </a:rPr>
-              <a:t>  •  </a:t>
-            </a:r>
-          </a:p>
-        </p:txBody>
-      </p:sp>
-      <p:sp>
-        <p:nvSpPr>
           <p:cNvPr id="22" name="TextBox 21"/>
           <p:cNvSpPr txBox="1"/>
           <p:nvPr/>
@@ -5491,40 +5522,6 @@
                 </a:solidFill>
               </a:rPr>
               <a:t>  •  đang lắng nghe nội bộ.</a:t>
-            </a:r>
-          </a:p>
-        </p:txBody>
-      </p:sp>
-      <p:sp>
-        <p:nvSpPr>
-          <p:cNvPr id="24" name="TextBox 23"/>
-          <p:cNvSpPr txBox="1"/>
-          <p:nvPr/>
-        </p:nvSpPr>
-        <p:spPr>
-          <a:xfrm>
-            <a:off x="6583680" y="3703319"/>
-            <a:ext cx="5212080" cy="365760"/>
-          </a:xfrm>
-          <a:prstGeom prst="rect">
-            <a:avLst/>
-          </a:prstGeom>
-          <a:noFill/>
-        </p:spPr>
-        <p:txBody>
-          <a:bodyPr wrap="square">
-            <a:spAutoFit/>
-          </a:bodyPr>
-          <a:lstStyle/>
-          <a:p>
-            <a:pPr algn="l"/>
-            <a:r>
-              <a:rPr sz="1300" b="0" i="0">
-                <a:solidFill>
-                  <a:srgbClr val="CCCCCC"/>
-                </a:solidFill>
-              </a:rPr>
-              <a:t>  •  </a:t>
             </a:r>
           </a:p>
         </p:txBody>
@@ -5603,6 +5600,7 @@
           <a:lstStyle/>
           <a:p>
             <a:pPr algn="ctr"/>
+            <a:endParaRPr/>
           </a:p>
         </p:txBody>
       </p:sp>
@@ -5649,7 +5647,7 @@
 </file>
 
 <file path=ppt/slides/slide13.xml><?xml version="1.0" encoding="utf-8"?>
-<p:sld xmlns:a="http://schemas.openxmlformats.org/drawingml/2006/main" xmlns:p="http://schemas.openxmlformats.org/presentationml/2006/main" xmlns:r="http://schemas.openxmlformats.org/officeDocument/2006/relationships">
+<p:sld xmlns:a="http://schemas.openxmlformats.org/drawingml/2006/main" xmlns:r="http://schemas.openxmlformats.org/officeDocument/2006/relationships" xmlns:p="http://schemas.openxmlformats.org/presentationml/2006/main">
   <p:cSld>
     <p:bg>
       <p:bgPr>
@@ -5665,7 +5663,14 @@
         <p:cNvGrpSpPr/>
         <p:nvPr/>
       </p:nvGrpSpPr>
-      <p:grpSpPr/>
+      <p:grpSpPr>
+        <a:xfrm>
+          <a:off x="0" y="0"/>
+          <a:ext cx="0" cy="0"/>
+          <a:chOff x="0" y="0"/>
+          <a:chExt cx="0" cy="0"/>
+        </a:xfrm>
+      </p:grpSpPr>
       <p:sp>
         <p:nvSpPr>
           <p:cNvPr id="2" name="Rectangle 1"/>
@@ -5706,6 +5711,7 @@
           <a:lstStyle/>
           <a:p>
             <a:pPr algn="ctr"/>
+            <a:endParaRPr/>
           </a:p>
         </p:txBody>
       </p:sp>
@@ -5749,6 +5755,7 @@
           <a:lstStyle/>
           <a:p>
             <a:pPr algn="ctr"/>
+            <a:endParaRPr/>
           </a:p>
         </p:txBody>
       </p:sp>
@@ -5860,6 +5867,7 @@
           <a:lstStyle/>
           <a:p>
             <a:pPr algn="ctr"/>
+            <a:endParaRPr/>
           </a:p>
         </p:txBody>
       </p:sp>
@@ -6073,6 +6081,7 @@
           <a:lstStyle/>
           <a:p>
             <a:pPr algn="ctr"/>
+            <a:endParaRPr/>
           </a:p>
         </p:txBody>
       </p:sp>
@@ -6355,6 +6364,7 @@
           <a:lstStyle/>
           <a:p>
             <a:pPr algn="ctr"/>
+            <a:endParaRPr/>
           </a:p>
         </p:txBody>
       </p:sp>
@@ -6401,7 +6411,7 @@
 </file>
 
 <file path=ppt/slides/slide14.xml><?xml version="1.0" encoding="utf-8"?>
-<p:sld xmlns:a="http://schemas.openxmlformats.org/drawingml/2006/main" xmlns:p="http://schemas.openxmlformats.org/presentationml/2006/main" xmlns:r="http://schemas.openxmlformats.org/officeDocument/2006/relationships">
+<p:sld xmlns:a="http://schemas.openxmlformats.org/drawingml/2006/main" xmlns:r="http://schemas.openxmlformats.org/officeDocument/2006/relationships" xmlns:p="http://schemas.openxmlformats.org/presentationml/2006/main">
   <p:cSld>
     <p:bg>
       <p:bgPr>
@@ -6417,7 +6427,14 @@
         <p:cNvGrpSpPr/>
         <p:nvPr/>
       </p:nvGrpSpPr>
-      <p:grpSpPr/>
+      <p:grpSpPr>
+        <a:xfrm>
+          <a:off x="0" y="0"/>
+          <a:ext cx="0" cy="0"/>
+          <a:chOff x="0" y="0"/>
+          <a:chExt cx="0" cy="0"/>
+        </a:xfrm>
+      </p:grpSpPr>
       <p:sp>
         <p:nvSpPr>
           <p:cNvPr id="2" name="Rectangle 1"/>
@@ -6458,6 +6475,7 @@
           <a:lstStyle/>
           <a:p>
             <a:pPr algn="ctr"/>
+            <a:endParaRPr/>
           </a:p>
         </p:txBody>
       </p:sp>
@@ -6501,6 +6519,7 @@
           <a:lstStyle/>
           <a:p>
             <a:pPr algn="ctr"/>
+            <a:endParaRPr/>
           </a:p>
         </p:txBody>
       </p:sp>
@@ -6513,7 +6532,7 @@
         <p:spPr>
           <a:xfrm>
             <a:off x="914400" y="914400"/>
-            <a:ext cx="10058400" cy="1097280"/>
+            <a:ext cx="10058400" cy="769441"/>
           </a:xfrm>
           <a:prstGeom prst="rect">
             <a:avLst/>
@@ -6528,13 +6547,26 @@
           <a:p>
             <a:pPr algn="ctr"/>
             <a:r>
-              <a:rPr sz="4400" b="1" i="0">
+              <a:rPr sz="4400" b="1" i="0" dirty="0">
                 <a:solidFill>
                   <a:srgbClr val="F5C518"/>
                 </a:solidFill>
               </a:rPr>
-              <a:t>CẢM ƠN THẦY CÔ &amp; HỘI ĐỔNG!</a:t>
-            </a:r>
+              <a:t>CẢM ƠN </a:t>
+            </a:r>
+            <a:r>
+              <a:rPr lang="vi-VN" sz="4400" b="1" i="0" dirty="0" smtClean="0">
+                <a:solidFill>
+                  <a:srgbClr val="F5C518"/>
+                </a:solidFill>
+              </a:rPr>
+              <a:t>đã lắng nghe</a:t>
+            </a:r>
+            <a:endParaRPr sz="4400" b="1" i="0" dirty="0">
+              <a:solidFill>
+                <a:srgbClr val="F5C518"/>
+              </a:solidFill>
+            </a:endParaRPr>
           </a:p>
         </p:txBody>
       </p:sp>
@@ -6612,6 +6644,7 @@
           <a:lstStyle/>
           <a:p>
             <a:pPr algn="ctr"/>
+            <a:endParaRPr/>
           </a:p>
         </p:txBody>
       </p:sp>
@@ -6655,6 +6688,7 @@
           <a:lstStyle/>
           <a:p>
             <a:pPr algn="ctr"/>
+            <a:endParaRPr/>
           </a:p>
         </p:txBody>
       </p:sp>
@@ -6698,6 +6732,7 @@
           <a:lstStyle/>
           <a:p>
             <a:pPr algn="ctr"/>
+            <a:endParaRPr/>
           </a:p>
         </p:txBody>
       </p:sp>
@@ -6809,6 +6844,7 @@
           <a:lstStyle/>
           <a:p>
             <a:pPr algn="ctr"/>
+            <a:endParaRPr/>
           </a:p>
         </p:txBody>
       </p:sp>
@@ -6852,6 +6888,7 @@
           <a:lstStyle/>
           <a:p>
             <a:pPr algn="ctr"/>
+            <a:endParaRPr/>
           </a:p>
         </p:txBody>
       </p:sp>
@@ -6963,6 +7000,7 @@
           <a:lstStyle/>
           <a:p>
             <a:pPr algn="ctr"/>
+            <a:endParaRPr/>
           </a:p>
         </p:txBody>
       </p:sp>
@@ -7006,6 +7044,7 @@
           <a:lstStyle/>
           <a:p>
             <a:pPr algn="ctr"/>
+            <a:endParaRPr/>
           </a:p>
         </p:txBody>
       </p:sp>
@@ -7117,6 +7156,7 @@
           <a:lstStyle/>
           <a:p>
             <a:pPr algn="ctr"/>
+            <a:endParaRPr/>
           </a:p>
         </p:txBody>
       </p:sp>
@@ -7160,6 +7200,7 @@
           <a:lstStyle/>
           <a:p>
             <a:pPr algn="ctr"/>
+            <a:endParaRPr/>
           </a:p>
         </p:txBody>
       </p:sp>
@@ -7274,7 +7315,7 @@
 </file>
 
 <file path=ppt/slides/slide2.xml><?xml version="1.0" encoding="utf-8"?>
-<p:sld xmlns:a="http://schemas.openxmlformats.org/drawingml/2006/main" xmlns:p="http://schemas.openxmlformats.org/presentationml/2006/main" xmlns:r="http://schemas.openxmlformats.org/officeDocument/2006/relationships">
+<p:sld xmlns:a="http://schemas.openxmlformats.org/drawingml/2006/main" xmlns:r="http://schemas.openxmlformats.org/officeDocument/2006/relationships" xmlns:p="http://schemas.openxmlformats.org/presentationml/2006/main">
   <p:cSld>
     <p:bg>
       <p:bgPr>
@@ -7290,7 +7331,14 @@
         <p:cNvGrpSpPr/>
         <p:nvPr/>
       </p:nvGrpSpPr>
-      <p:grpSpPr/>
+      <p:grpSpPr>
+        <a:xfrm>
+          <a:off x="0" y="0"/>
+          <a:ext cx="0" cy="0"/>
+          <a:chOff x="0" y="0"/>
+          <a:chExt cx="0" cy="0"/>
+        </a:xfrm>
+      </p:grpSpPr>
       <p:sp>
         <p:nvSpPr>
           <p:cNvPr id="2" name="Rectangle 1"/>
@@ -7331,6 +7379,7 @@
           <a:lstStyle/>
           <a:p>
             <a:pPr algn="ctr"/>
+            <a:endParaRPr/>
           </a:p>
         </p:txBody>
       </p:sp>
@@ -7374,6 +7423,7 @@
           <a:lstStyle/>
           <a:p>
             <a:pPr algn="ctr"/>
+            <a:endParaRPr/>
           </a:p>
         </p:txBody>
       </p:sp>
@@ -7485,6 +7535,7 @@
           <a:lstStyle/>
           <a:p>
             <a:pPr algn="ctr"/>
+            <a:endParaRPr/>
           </a:p>
         </p:txBody>
       </p:sp>
@@ -7766,6 +7817,7 @@
           <a:lstStyle/>
           <a:p>
             <a:pPr algn="ctr"/>
+            <a:endParaRPr/>
           </a:p>
         </p:txBody>
       </p:sp>
@@ -7815,7 +7867,7 @@
 </file>
 
 <file path=ppt/slides/slide3.xml><?xml version="1.0" encoding="utf-8"?>
-<p:sld xmlns:a="http://schemas.openxmlformats.org/drawingml/2006/main" xmlns:p="http://schemas.openxmlformats.org/presentationml/2006/main" xmlns:r="http://schemas.openxmlformats.org/officeDocument/2006/relationships">
+<p:sld xmlns:a="http://schemas.openxmlformats.org/drawingml/2006/main" xmlns:r="http://schemas.openxmlformats.org/officeDocument/2006/relationships" xmlns:p="http://schemas.openxmlformats.org/presentationml/2006/main">
   <p:cSld>
     <p:bg>
       <p:bgPr>
@@ -7831,7 +7883,14 @@
         <p:cNvGrpSpPr/>
         <p:nvPr/>
       </p:nvGrpSpPr>
-      <p:grpSpPr/>
+      <p:grpSpPr>
+        <a:xfrm>
+          <a:off x="0" y="0"/>
+          <a:ext cx="0" cy="0"/>
+          <a:chOff x="0" y="0"/>
+          <a:chExt cx="0" cy="0"/>
+        </a:xfrm>
+      </p:grpSpPr>
       <p:sp>
         <p:nvSpPr>
           <p:cNvPr id="2" name="Rectangle 1"/>
@@ -7872,6 +7931,7 @@
           <a:lstStyle/>
           <a:p>
             <a:pPr algn="ctr"/>
+            <a:endParaRPr/>
           </a:p>
         </p:txBody>
       </p:sp>
@@ -7915,6 +7975,7 @@
           <a:lstStyle/>
           <a:p>
             <a:pPr algn="ctr"/>
+            <a:endParaRPr/>
           </a:p>
         </p:txBody>
       </p:sp>
@@ -8026,6 +8087,7 @@
           <a:lstStyle/>
           <a:p>
             <a:pPr algn="ctr"/>
+            <a:endParaRPr/>
           </a:p>
         </p:txBody>
       </p:sp>
@@ -8069,6 +8131,7 @@
           <a:lstStyle/>
           <a:p>
             <a:pPr algn="ctr"/>
+            <a:endParaRPr/>
           </a:p>
         </p:txBody>
       </p:sp>
@@ -8146,6 +8209,7 @@
           <a:lstStyle/>
           <a:p>
             <a:pPr algn="ctr"/>
+            <a:endParaRPr/>
           </a:p>
         </p:txBody>
       </p:sp>
@@ -8223,6 +8287,7 @@
           <a:lstStyle/>
           <a:p>
             <a:pPr algn="ctr"/>
+            <a:endParaRPr/>
           </a:p>
         </p:txBody>
       </p:sp>
@@ -8300,6 +8365,7 @@
           <a:lstStyle/>
           <a:p>
             <a:pPr algn="ctr"/>
+            <a:endParaRPr/>
           </a:p>
         </p:txBody>
       </p:sp>
@@ -8377,6 +8443,7 @@
           <a:lstStyle/>
           <a:p>
             <a:pPr algn="ctr"/>
+            <a:endParaRPr/>
           </a:p>
         </p:txBody>
       </p:sp>
@@ -8454,6 +8521,7 @@
           <a:lstStyle/>
           <a:p>
             <a:pPr algn="ctr"/>
+            <a:endParaRPr/>
           </a:p>
         </p:txBody>
       </p:sp>
@@ -8531,6 +8599,7 @@
           <a:lstStyle/>
           <a:p>
             <a:pPr algn="ctr"/>
+            <a:endParaRPr/>
           </a:p>
         </p:txBody>
       </p:sp>
@@ -8608,6 +8677,7 @@
           <a:lstStyle/>
           <a:p>
             <a:pPr algn="ctr"/>
+            <a:endParaRPr/>
           </a:p>
         </p:txBody>
       </p:sp>
@@ -8685,6 +8755,7 @@
           <a:lstStyle/>
           <a:p>
             <a:pPr algn="ctr"/>
+            <a:endParaRPr/>
           </a:p>
         </p:txBody>
       </p:sp>
@@ -8796,6 +8867,7 @@
           <a:lstStyle/>
           <a:p>
             <a:pPr algn="ctr"/>
+            <a:endParaRPr/>
           </a:p>
         </p:txBody>
       </p:sp>
@@ -8951,7 +9023,7 @@
 </file>
 
 <file path=ppt/slides/slide4.xml><?xml version="1.0" encoding="utf-8"?>
-<p:sld xmlns:a="http://schemas.openxmlformats.org/drawingml/2006/main" xmlns:p="http://schemas.openxmlformats.org/presentationml/2006/main" xmlns:r="http://schemas.openxmlformats.org/officeDocument/2006/relationships">
+<p:sld xmlns:a="http://schemas.openxmlformats.org/drawingml/2006/main" xmlns:r="http://schemas.openxmlformats.org/officeDocument/2006/relationships" xmlns:p="http://schemas.openxmlformats.org/presentationml/2006/main">
   <p:cSld>
     <p:bg>
       <p:bgPr>
@@ -8967,7 +9039,14 @@
         <p:cNvGrpSpPr/>
         <p:nvPr/>
       </p:nvGrpSpPr>
-      <p:grpSpPr/>
+      <p:grpSpPr>
+        <a:xfrm>
+          <a:off x="0" y="0"/>
+          <a:ext cx="0" cy="0"/>
+          <a:chOff x="0" y="0"/>
+          <a:chExt cx="0" cy="0"/>
+        </a:xfrm>
+      </p:grpSpPr>
       <p:sp>
         <p:nvSpPr>
           <p:cNvPr id="2" name="Rectangle 1"/>
@@ -9008,6 +9087,7 @@
           <a:lstStyle/>
           <a:p>
             <a:pPr algn="ctr"/>
+            <a:endParaRPr/>
           </a:p>
         </p:txBody>
       </p:sp>
@@ -9051,6 +9131,7 @@
           <a:lstStyle/>
           <a:p>
             <a:pPr algn="ctr"/>
+            <a:endParaRPr/>
           </a:p>
         </p:txBody>
       </p:sp>
@@ -9162,6 +9243,7 @@
           <a:lstStyle/>
           <a:p>
             <a:pPr algn="ctr"/>
+            <a:endParaRPr/>
           </a:p>
         </p:txBody>
       </p:sp>
@@ -9291,12 +9373,188 @@
           <a:p>
             <a:pPr algn="l"/>
             <a:r>
-              <a:rPr sz="1400" b="0" i="0">
+              <a:rPr sz="1400" b="0" i="0" dirty="0">
                 <a:solidFill>
                   <a:srgbClr val="CCCCCC"/>
                 </a:solidFill>
               </a:rPr>
-              <a:t>  •  Swagger UI tự động đọc code C# → Sinh trang tài liệu tương tác đầy đủ.</a:t>
+              <a:t>  •  Swagger UI </a:t>
+            </a:r>
+            <a:r>
+              <a:rPr sz="1400" b="0" i="0" dirty="0" err="1">
+                <a:solidFill>
+                  <a:srgbClr val="CCCCCC"/>
+                </a:solidFill>
+              </a:rPr>
+              <a:t>tự</a:t>
+            </a:r>
+            <a:r>
+              <a:rPr sz="1400" b="0" i="0" dirty="0">
+                <a:solidFill>
+                  <a:srgbClr val="CCCCCC"/>
+                </a:solidFill>
+              </a:rPr>
+              <a:t> </a:t>
+            </a:r>
+            <a:r>
+              <a:rPr sz="1400" b="0" i="0" dirty="0" err="1">
+                <a:solidFill>
+                  <a:srgbClr val="CCCCCC"/>
+                </a:solidFill>
+              </a:rPr>
+              <a:t>động</a:t>
+            </a:r>
+            <a:r>
+              <a:rPr sz="1400" b="0" i="0" dirty="0">
+                <a:solidFill>
+                  <a:srgbClr val="CCCCCC"/>
+                </a:solidFill>
+              </a:rPr>
+              <a:t> </a:t>
+            </a:r>
+            <a:r>
+              <a:rPr sz="1400" b="0" i="0" dirty="0" err="1">
+                <a:solidFill>
+                  <a:srgbClr val="CCCCCC"/>
+                </a:solidFill>
+              </a:rPr>
+              <a:t>đọc</a:t>
+            </a:r>
+            <a:r>
+              <a:rPr sz="1400" b="0" i="0" dirty="0">
+                <a:solidFill>
+                  <a:srgbClr val="CCCCCC"/>
+                </a:solidFill>
+              </a:rPr>
+              <a:t> code C# → </a:t>
+            </a:r>
+            <a:r>
+              <a:rPr sz="1400" b="0" i="0" dirty="0" err="1">
+                <a:solidFill>
+                  <a:srgbClr val="CCCCCC"/>
+                </a:solidFill>
+              </a:rPr>
+              <a:t>Sinh</a:t>
+            </a:r>
+            <a:r>
+              <a:rPr sz="1400" b="0" i="0" dirty="0">
+                <a:solidFill>
+                  <a:srgbClr val="CCCCCC"/>
+                </a:solidFill>
+              </a:rPr>
+              <a:t> </a:t>
+            </a:r>
+            <a:r>
+              <a:rPr sz="1400" b="0" i="0" dirty="0" err="1">
+                <a:solidFill>
+                  <a:srgbClr val="CCCCCC"/>
+                </a:solidFill>
+              </a:rPr>
+              <a:t>trang</a:t>
+            </a:r>
+            <a:r>
+              <a:rPr sz="1400" b="0" i="0" dirty="0">
+                <a:solidFill>
+                  <a:srgbClr val="CCCCCC"/>
+                </a:solidFill>
+              </a:rPr>
+              <a:t> </a:t>
+            </a:r>
+            <a:r>
+              <a:rPr sz="1400" b="0" i="0" dirty="0" err="1">
+                <a:solidFill>
+                  <a:srgbClr val="CCCCCC"/>
+                </a:solidFill>
+              </a:rPr>
+              <a:t>tài</a:t>
+            </a:r>
+            <a:r>
+              <a:rPr sz="1400" b="0" i="0" dirty="0">
+                <a:solidFill>
+                  <a:srgbClr val="CCCCCC"/>
+                </a:solidFill>
+              </a:rPr>
+              <a:t> </a:t>
+            </a:r>
+            <a:r>
+              <a:rPr sz="1400" b="0" i="0" dirty="0" err="1">
+                <a:solidFill>
+                  <a:srgbClr val="CCCCCC"/>
+                </a:solidFill>
+              </a:rPr>
+              <a:t>liệu</a:t>
+            </a:r>
+            <a:r>
+              <a:rPr sz="1400" b="0" i="0" dirty="0">
+                <a:solidFill>
+                  <a:srgbClr val="CCCCCC"/>
+                </a:solidFill>
+              </a:rPr>
+              <a:t> </a:t>
+            </a:r>
+            <a:r>
+              <a:rPr sz="1400" b="0" i="0" dirty="0" err="1">
+                <a:solidFill>
+                  <a:srgbClr val="CCCCCC"/>
+                </a:solidFill>
+              </a:rPr>
+              <a:t>tương</a:t>
+            </a:r>
+            <a:r>
+              <a:rPr sz="1400" b="0" i="0" dirty="0">
+                <a:solidFill>
+                  <a:srgbClr val="CCCCCC"/>
+                </a:solidFill>
+              </a:rPr>
+              <a:t> </a:t>
+            </a:r>
+            <a:r>
+              <a:rPr sz="1400" b="0" i="0" dirty="0" err="1">
+                <a:solidFill>
+                  <a:srgbClr val="CCCCCC"/>
+                </a:solidFill>
+              </a:rPr>
+              <a:t>tác</a:t>
+            </a:r>
+            <a:r>
+              <a:rPr sz="1400" b="0" i="0" dirty="0">
+                <a:solidFill>
+                  <a:srgbClr val="CCCCCC"/>
+                </a:solidFill>
+              </a:rPr>
+              <a:t> </a:t>
+            </a:r>
+            <a:r>
+              <a:rPr sz="1400" b="0" i="0" dirty="0" err="1">
+                <a:solidFill>
+                  <a:srgbClr val="CCCCCC"/>
+                </a:solidFill>
+              </a:rPr>
+              <a:t>đầy</a:t>
+            </a:r>
+            <a:r>
+              <a:rPr sz="1400" b="0" i="0" dirty="0">
+                <a:solidFill>
+                  <a:srgbClr val="CCCCCC"/>
+                </a:solidFill>
+              </a:rPr>
+              <a:t> </a:t>
+            </a:r>
+            <a:r>
+              <a:rPr sz="1400" b="0" i="0" dirty="0" err="1">
+                <a:solidFill>
+                  <a:srgbClr val="CCCCCC"/>
+                </a:solidFill>
+              </a:rPr>
+              <a:t>đủ</a:t>
+            </a:r>
+            <a:r>
+              <a:rPr sz="1400" b="0" i="0" dirty="0">
+                <a:solidFill>
+                  <a:srgbClr val="CCCCCC"/>
+                </a:solidFill>
+              </a:rPr>
+              <a:t>.</a:t>
             </a:r>
           </a:p>
         </p:txBody>
@@ -9359,12 +9617,156 @@
           <a:p>
             <a:pPr algn="l"/>
             <a:r>
-              <a:rPr sz="1400" b="0" i="0">
+              <a:rPr sz="1400" b="0" i="0" dirty="0">
                 <a:solidFill>
                   <a:srgbClr val="CCCCCC"/>
                 </a:solidFill>
               </a:rPr>
-              <a:t>  •  Hiển thị đầy đủ 2 endpoints, mô tả tham số và response schema.</a:t>
+              <a:t>  •  </a:t>
+            </a:r>
+            <a:r>
+              <a:rPr sz="1400" b="0" i="0" dirty="0" err="1">
+                <a:solidFill>
+                  <a:srgbClr val="CCCCCC"/>
+                </a:solidFill>
+              </a:rPr>
+              <a:t>Hiển</a:t>
+            </a:r>
+            <a:r>
+              <a:rPr sz="1400" b="0" i="0" dirty="0">
+                <a:solidFill>
+                  <a:srgbClr val="CCCCCC"/>
+                </a:solidFill>
+              </a:rPr>
+              <a:t> </a:t>
+            </a:r>
+            <a:r>
+              <a:rPr sz="1400" b="0" i="0" dirty="0" err="1">
+                <a:solidFill>
+                  <a:srgbClr val="CCCCCC"/>
+                </a:solidFill>
+              </a:rPr>
+              <a:t>thị</a:t>
+            </a:r>
+            <a:r>
+              <a:rPr sz="1400" b="0" i="0" dirty="0">
+                <a:solidFill>
+                  <a:srgbClr val="CCCCCC"/>
+                </a:solidFill>
+              </a:rPr>
+              <a:t> </a:t>
+            </a:r>
+            <a:r>
+              <a:rPr sz="1400" b="0" i="0" dirty="0" err="1">
+                <a:solidFill>
+                  <a:srgbClr val="CCCCCC"/>
+                </a:solidFill>
+              </a:rPr>
+              <a:t>đầy</a:t>
+            </a:r>
+            <a:r>
+              <a:rPr sz="1400" b="0" i="0" dirty="0">
+                <a:solidFill>
+                  <a:srgbClr val="CCCCCC"/>
+                </a:solidFill>
+              </a:rPr>
+              <a:t> </a:t>
+            </a:r>
+            <a:r>
+              <a:rPr sz="1400" b="0" i="0" dirty="0" err="1">
+                <a:solidFill>
+                  <a:srgbClr val="CCCCCC"/>
+                </a:solidFill>
+              </a:rPr>
+              <a:t>đủ</a:t>
+            </a:r>
+            <a:r>
+              <a:rPr sz="1400" b="0" i="0" dirty="0">
+                <a:solidFill>
+                  <a:srgbClr val="CCCCCC"/>
+                </a:solidFill>
+              </a:rPr>
+              <a:t> 2 endpoints, </a:t>
+            </a:r>
+            <a:r>
+              <a:rPr sz="1400" b="0" i="0" dirty="0" err="1">
+                <a:solidFill>
+                  <a:srgbClr val="CCCCCC"/>
+                </a:solidFill>
+              </a:rPr>
+              <a:t>mô</a:t>
+            </a:r>
+            <a:r>
+              <a:rPr sz="1400" b="0" i="0" dirty="0">
+                <a:solidFill>
+                  <a:srgbClr val="CCCCCC"/>
+                </a:solidFill>
+              </a:rPr>
+              <a:t> </a:t>
+            </a:r>
+            <a:r>
+              <a:rPr sz="1400" b="0" i="0" dirty="0" err="1">
+                <a:solidFill>
+                  <a:srgbClr val="CCCCCC"/>
+                </a:solidFill>
+              </a:rPr>
+              <a:t>tả</a:t>
+            </a:r>
+            <a:r>
+              <a:rPr sz="1400" b="0" i="0" dirty="0">
+                <a:solidFill>
+                  <a:srgbClr val="CCCCCC"/>
+                </a:solidFill>
+              </a:rPr>
+              <a:t> </a:t>
+            </a:r>
+            <a:r>
+              <a:rPr sz="1400" b="0" i="0" dirty="0" err="1">
+                <a:solidFill>
+                  <a:srgbClr val="CCCCCC"/>
+                </a:solidFill>
+              </a:rPr>
+              <a:t>tham</a:t>
+            </a:r>
+            <a:r>
+              <a:rPr sz="1400" b="0" i="0" dirty="0">
+                <a:solidFill>
+                  <a:srgbClr val="CCCCCC"/>
+                </a:solidFill>
+              </a:rPr>
+              <a:t> </a:t>
+            </a:r>
+            <a:r>
+              <a:rPr sz="1400" b="0" i="0" dirty="0" err="1">
+                <a:solidFill>
+                  <a:srgbClr val="CCCCCC"/>
+                </a:solidFill>
+              </a:rPr>
+              <a:t>số</a:t>
+            </a:r>
+            <a:r>
+              <a:rPr sz="1400" b="0" i="0" dirty="0">
+                <a:solidFill>
+                  <a:srgbClr val="CCCCCC"/>
+                </a:solidFill>
+              </a:rPr>
+              <a:t> </a:t>
+            </a:r>
+            <a:r>
+              <a:rPr sz="1400" b="0" i="0" dirty="0" err="1">
+                <a:solidFill>
+                  <a:srgbClr val="CCCCCC"/>
+                </a:solidFill>
+              </a:rPr>
+              <a:t>và</a:t>
+            </a:r>
+            <a:r>
+              <a:rPr sz="1400" b="0" i="0" dirty="0">
+                <a:solidFill>
+                  <a:srgbClr val="CCCCCC"/>
+                </a:solidFill>
+              </a:rPr>
+              <a:t> response schema.</a:t>
             </a:r>
           </a:p>
         </p:txBody>
@@ -9477,6 +9879,7 @@
           <a:lstStyle/>
           <a:p>
             <a:pPr algn="ctr"/>
+            <a:endParaRPr/>
           </a:p>
         </p:txBody>
       </p:sp>
@@ -9523,7 +9926,7 @@
 </file>
 
 <file path=ppt/slides/slide5.xml><?xml version="1.0" encoding="utf-8"?>
-<p:sld xmlns:a="http://schemas.openxmlformats.org/drawingml/2006/main" xmlns:p="http://schemas.openxmlformats.org/presentationml/2006/main" xmlns:r="http://schemas.openxmlformats.org/officeDocument/2006/relationships">
+<p:sld xmlns:a="http://schemas.openxmlformats.org/drawingml/2006/main" xmlns:r="http://schemas.openxmlformats.org/officeDocument/2006/relationships" xmlns:p="http://schemas.openxmlformats.org/presentationml/2006/main">
   <p:cSld>
     <p:bg>
       <p:bgPr>
@@ -9539,7 +9942,14 @@
         <p:cNvGrpSpPr/>
         <p:nvPr/>
       </p:nvGrpSpPr>
-      <p:grpSpPr/>
+      <p:grpSpPr>
+        <a:xfrm>
+          <a:off x="0" y="0"/>
+          <a:ext cx="0" cy="0"/>
+          <a:chOff x="0" y="0"/>
+          <a:chExt cx="0" cy="0"/>
+        </a:xfrm>
+      </p:grpSpPr>
       <p:sp>
         <p:nvSpPr>
           <p:cNvPr id="2" name="Rectangle 1"/>
@@ -9580,6 +9990,7 @@
           <a:lstStyle/>
           <a:p>
             <a:pPr algn="ctr"/>
+            <a:endParaRPr/>
           </a:p>
         </p:txBody>
       </p:sp>
@@ -9623,6 +10034,7 @@
           <a:lstStyle/>
           <a:p>
             <a:pPr algn="ctr"/>
+            <a:endParaRPr/>
           </a:p>
         </p:txBody>
       </p:sp>
@@ -9734,6 +10146,7 @@
           <a:lstStyle/>
           <a:p>
             <a:pPr algn="ctr"/>
+            <a:endParaRPr/>
           </a:p>
         </p:txBody>
       </p:sp>
@@ -9845,6 +10258,7 @@
           <a:lstStyle/>
           <a:p>
             <a:pPr algn="ctr"/>
+            <a:endParaRPr/>
           </a:p>
         </p:txBody>
       </p:sp>
@@ -9888,6 +10302,7 @@
           <a:lstStyle/>
           <a:p>
             <a:pPr algn="ctr"/>
+            <a:endParaRPr/>
           </a:p>
         </p:txBody>
       </p:sp>
@@ -10033,6 +10448,7 @@
           <a:lstStyle/>
           <a:p>
             <a:pPr algn="ctr"/>
+            <a:endParaRPr/>
           </a:p>
         </p:txBody>
       </p:sp>
@@ -10145,6 +10561,7 @@
           <a:lstStyle/>
           <a:p>
             <a:pPr algn="ctr"/>
+            <a:endParaRPr/>
           </a:p>
         </p:txBody>
       </p:sp>
@@ -10188,6 +10605,7 @@
           <a:lstStyle/>
           <a:p>
             <a:pPr algn="ctr"/>
+            <a:endParaRPr/>
           </a:p>
         </p:txBody>
       </p:sp>
@@ -10333,6 +10751,7 @@
           <a:lstStyle/>
           <a:p>
             <a:pPr algn="ctr"/>
+            <a:endParaRPr/>
           </a:p>
         </p:txBody>
       </p:sp>
@@ -10444,6 +10863,7 @@
           <a:lstStyle/>
           <a:p>
             <a:pPr algn="ctr"/>
+            <a:endParaRPr/>
           </a:p>
         </p:txBody>
       </p:sp>
@@ -10490,7 +10910,7 @@
 </file>
 
 <file path=ppt/slides/slide6.xml><?xml version="1.0" encoding="utf-8"?>
-<p:sld xmlns:a="http://schemas.openxmlformats.org/drawingml/2006/main" xmlns:p="http://schemas.openxmlformats.org/presentationml/2006/main" xmlns:r="http://schemas.openxmlformats.org/officeDocument/2006/relationships">
+<p:sld xmlns:a="http://schemas.openxmlformats.org/drawingml/2006/main" xmlns:r="http://schemas.openxmlformats.org/officeDocument/2006/relationships" xmlns:p="http://schemas.openxmlformats.org/presentationml/2006/main">
   <p:cSld>
     <p:bg>
       <p:bgPr>
@@ -10506,7 +10926,14 @@
         <p:cNvGrpSpPr/>
         <p:nvPr/>
       </p:nvGrpSpPr>
-      <p:grpSpPr/>
+      <p:grpSpPr>
+        <a:xfrm>
+          <a:off x="0" y="0"/>
+          <a:ext cx="0" cy="0"/>
+          <a:chOff x="0" y="0"/>
+          <a:chExt cx="0" cy="0"/>
+        </a:xfrm>
+      </p:grpSpPr>
       <p:sp>
         <p:nvSpPr>
           <p:cNvPr id="2" name="Rectangle 1"/>
@@ -10547,6 +10974,7 @@
           <a:lstStyle/>
           <a:p>
             <a:pPr algn="ctr"/>
+            <a:endParaRPr/>
           </a:p>
         </p:txBody>
       </p:sp>
@@ -10590,6 +11018,7 @@
           <a:lstStyle/>
           <a:p>
             <a:pPr algn="ctr"/>
+            <a:endParaRPr/>
           </a:p>
         </p:txBody>
       </p:sp>
@@ -10701,6 +11130,7 @@
           <a:lstStyle/>
           <a:p>
             <a:pPr algn="ctr"/>
+            <a:endParaRPr/>
           </a:p>
         </p:txBody>
       </p:sp>
@@ -10778,6 +11208,7 @@
           <a:lstStyle/>
           <a:p>
             <a:pPr algn="ctr"/>
+            <a:endParaRPr/>
           </a:p>
         </p:txBody>
       </p:sp>
@@ -11137,7 +11568,7 @@
 </file>
 
 <file path=ppt/slides/slide7.xml><?xml version="1.0" encoding="utf-8"?>
-<p:sld xmlns:a="http://schemas.openxmlformats.org/drawingml/2006/main" xmlns:p="http://schemas.openxmlformats.org/presentationml/2006/main" xmlns:r="http://schemas.openxmlformats.org/officeDocument/2006/relationships">
+<p:sld xmlns:a="http://schemas.openxmlformats.org/drawingml/2006/main" xmlns:r="http://schemas.openxmlformats.org/officeDocument/2006/relationships" xmlns:p="http://schemas.openxmlformats.org/presentationml/2006/main">
   <p:cSld>
     <p:bg>
       <p:bgPr>
@@ -11153,7 +11584,14 @@
         <p:cNvGrpSpPr/>
         <p:nvPr/>
       </p:nvGrpSpPr>
-      <p:grpSpPr/>
+      <p:grpSpPr>
+        <a:xfrm>
+          <a:off x="0" y="0"/>
+          <a:ext cx="0" cy="0"/>
+          <a:chOff x="0" y="0"/>
+          <a:chExt cx="0" cy="0"/>
+        </a:xfrm>
+      </p:grpSpPr>
       <p:sp>
         <p:nvSpPr>
           <p:cNvPr id="2" name="Rectangle 1"/>
@@ -11194,6 +11632,7 @@
           <a:lstStyle/>
           <a:p>
             <a:pPr algn="ctr"/>
+            <a:endParaRPr/>
           </a:p>
         </p:txBody>
       </p:sp>
@@ -11237,6 +11676,7 @@
           <a:lstStyle/>
           <a:p>
             <a:pPr algn="ctr"/>
+            <a:endParaRPr/>
           </a:p>
         </p:txBody>
       </p:sp>
@@ -11348,6 +11788,7 @@
           <a:lstStyle/>
           <a:p>
             <a:pPr algn="ctr"/>
+            <a:endParaRPr/>
           </a:p>
         </p:txBody>
       </p:sp>
@@ -11629,6 +12070,7 @@
           <a:lstStyle/>
           <a:p>
             <a:pPr algn="ctr"/>
+            <a:endParaRPr/>
           </a:p>
         </p:txBody>
       </p:sp>
@@ -11706,6 +12148,7 @@
           <a:lstStyle/>
           <a:p>
             <a:pPr algn="ctr"/>
+            <a:endParaRPr/>
           </a:p>
         </p:txBody>
       </p:sp>
@@ -11752,7 +12195,7 @@
 </file>
 
 <file path=ppt/slides/slide8.xml><?xml version="1.0" encoding="utf-8"?>
-<p:sld xmlns:a="http://schemas.openxmlformats.org/drawingml/2006/main" xmlns:p="http://schemas.openxmlformats.org/presentationml/2006/main" xmlns:r="http://schemas.openxmlformats.org/officeDocument/2006/relationships">
+<p:sld xmlns:a="http://schemas.openxmlformats.org/drawingml/2006/main" xmlns:r="http://schemas.openxmlformats.org/officeDocument/2006/relationships" xmlns:p="http://schemas.openxmlformats.org/presentationml/2006/main">
   <p:cSld>
     <p:bg>
       <p:bgPr>
@@ -11768,7 +12211,14 @@
         <p:cNvGrpSpPr/>
         <p:nvPr/>
       </p:nvGrpSpPr>
-      <p:grpSpPr/>
+      <p:grpSpPr>
+        <a:xfrm>
+          <a:off x="0" y="0"/>
+          <a:ext cx="0" cy="0"/>
+          <a:chOff x="0" y="0"/>
+          <a:chExt cx="0" cy="0"/>
+        </a:xfrm>
+      </p:grpSpPr>
       <p:sp>
         <p:nvSpPr>
           <p:cNvPr id="2" name="Rectangle 1"/>
@@ -11809,6 +12259,7 @@
           <a:lstStyle/>
           <a:p>
             <a:pPr algn="ctr"/>
+            <a:endParaRPr/>
           </a:p>
         </p:txBody>
       </p:sp>
@@ -11852,6 +12303,7 @@
           <a:lstStyle/>
           <a:p>
             <a:pPr algn="ctr"/>
+            <a:endParaRPr/>
           </a:p>
         </p:txBody>
       </p:sp>
@@ -11963,6 +12415,7 @@
           <a:lstStyle/>
           <a:p>
             <a:pPr algn="ctr"/>
+            <a:endParaRPr/>
           </a:p>
         </p:txBody>
       </p:sp>
@@ -12176,6 +12629,7 @@
           <a:lstStyle/>
           <a:p>
             <a:pPr algn="ctr"/>
+            <a:endParaRPr/>
           </a:p>
         </p:txBody>
       </p:sp>
@@ -12227,7 +12681,7 @@
 </file>
 
 <file path=ppt/slides/slide9.xml><?xml version="1.0" encoding="utf-8"?>
-<p:sld xmlns:a="http://schemas.openxmlformats.org/drawingml/2006/main" xmlns:p="http://schemas.openxmlformats.org/presentationml/2006/main" xmlns:r="http://schemas.openxmlformats.org/officeDocument/2006/relationships">
+<p:sld xmlns:a="http://schemas.openxmlformats.org/drawingml/2006/main" xmlns:r="http://schemas.openxmlformats.org/officeDocument/2006/relationships" xmlns:p="http://schemas.openxmlformats.org/presentationml/2006/main">
   <p:cSld>
     <p:bg>
       <p:bgPr>
@@ -12243,7 +12697,14 @@
         <p:cNvGrpSpPr/>
         <p:nvPr/>
       </p:nvGrpSpPr>
-      <p:grpSpPr/>
+      <p:grpSpPr>
+        <a:xfrm>
+          <a:off x="0" y="0"/>
+          <a:ext cx="0" cy="0"/>
+          <a:chOff x="0" y="0"/>
+          <a:chExt cx="0" cy="0"/>
+        </a:xfrm>
+      </p:grpSpPr>
       <p:sp>
         <p:nvSpPr>
           <p:cNvPr id="2" name="Rectangle 1"/>
@@ -12284,6 +12745,7 @@
           <a:lstStyle/>
           <a:p>
             <a:pPr algn="ctr"/>
+            <a:endParaRPr/>
           </a:p>
         </p:txBody>
       </p:sp>
@@ -12327,6 +12789,7 @@
           <a:lstStyle/>
           <a:p>
             <a:pPr algn="ctr"/>
+            <a:endParaRPr/>
           </a:p>
         </p:txBody>
       </p:sp>
@@ -12438,6 +12901,7 @@
           <a:lstStyle/>
           <a:p>
             <a:pPr algn="ctr"/>
+            <a:endParaRPr/>
           </a:p>
         </p:txBody>
       </p:sp>
@@ -12515,6 +12979,7 @@
           <a:lstStyle/>
           <a:p>
             <a:pPr algn="ctr"/>
+            <a:endParaRPr/>
           </a:p>
         </p:txBody>
       </p:sp>

</xml_diff>